<commit_message>
Expand progress deck with architecture and code stats
</commit_message>
<xml_diff>
--- a/artifacts/calibration_output/project_progress_summary_2026-04-22.pptx
+++ b/artifacts/calibration_output/project_progress_summary_2026-04-22.pptx
@@ -14,6 +14,7 @@
     <p:sldId id="262" r:id="rId13"/>
     <p:sldId id="263" r:id="rId14"/>
     <p:sldId id="264" r:id="rId15"/>
+    <p:sldId id="265" r:id="rId16"/>
   </p:sldIdLst>
   <p:sldSz cx="12188952" cy="6858000" type="screen4x3"/>
   <p:notesSz cx="6858000" cy="9144000"/>
@@ -3806,6 +3807,635 @@
 </p:sld>
 </file>
 
+<file path=ppt/slides/slide10.xml><?xml version="1.0" encoding="utf-8"?>
+<p:sld xmlns:a="http://schemas.openxmlformats.org/drawingml/2006/main" xmlns:p="http://schemas.openxmlformats.org/presentationml/2006/main" xmlns:r="http://schemas.openxmlformats.org/officeDocument/2006/relationships">
+  <p:cSld>
+    <p:spTree>
+      <p:nvGrpSpPr>
+        <p:cNvPr id="1" name=""/>
+        <p:cNvGrpSpPr/>
+        <p:nvPr/>
+      </p:nvGrpSpPr>
+      <p:grpSpPr/>
+      <p:sp>
+        <p:nvSpPr>
+          <p:cNvPr id="2" name="Rectangle 1"/>
+          <p:cNvSpPr/>
+          <p:nvPr/>
+        </p:nvSpPr>
+        <p:spPr>
+          <a:xfrm>
+            <a:off x="0" y="0"/>
+            <a:ext cx="12191695" cy="6858000"/>
+          </a:xfrm>
+          <a:prstGeom prst="rect">
+            <a:avLst/>
+          </a:prstGeom>
+          <a:solidFill>
+            <a:srgbClr val="F5F1E8"/>
+          </a:solidFill>
+          <a:ln>
+            <a:noFill/>
+          </a:ln>
+        </p:spPr>
+        <p:style>
+          <a:lnRef idx="1">
+            <a:schemeClr val="accent1"/>
+          </a:lnRef>
+          <a:fillRef idx="3">
+            <a:schemeClr val="accent1"/>
+          </a:fillRef>
+          <a:effectRef idx="2">
+            <a:schemeClr val="accent1"/>
+          </a:effectRef>
+          <a:fontRef idx="minor">
+            <a:schemeClr val="lt1"/>
+          </a:fontRef>
+        </p:style>
+        <p:txBody>
+          <a:bodyPr rtlCol="0" anchor="ctr"/>
+          <a:lstStyle/>
+          <a:p>
+            <a:pPr algn="ctr"/>
+          </a:p>
+        </p:txBody>
+      </p:sp>
+      <p:sp>
+        <p:nvSpPr>
+          <p:cNvPr id="3" name="TextBox 2"/>
+          <p:cNvSpPr txBox="1"/>
+          <p:nvPr/>
+        </p:nvSpPr>
+        <p:spPr>
+          <a:xfrm>
+            <a:off x="658368" y="402336"/>
+            <a:ext cx="3108960" cy="438912"/>
+          </a:xfrm>
+          <a:prstGeom prst="rect">
+            <a:avLst/>
+          </a:prstGeom>
+          <a:noFill/>
+        </p:spPr>
+        <p:txBody>
+          <a:bodyPr wrap="square">
+            <a:spAutoFit/>
+          </a:bodyPr>
+          <a:lstStyle/>
+          <a:p>
+            <a:pPr algn="l"/>
+            <a:r>
+              <a:rPr sz="2400" b="1">
+                <a:solidFill>
+                  <a:srgbClr val="17324D"/>
+                </a:solidFill>
+                <a:latin typeface="PingFang SC"/>
+              </a:rPr>
+              <a:t>9. 下一步建议</a:t>
+            </a:r>
+          </a:p>
+        </p:txBody>
+      </p:sp>
+      <p:sp>
+        <p:nvSpPr>
+          <p:cNvPr id="4" name="TextBox 3"/>
+          <p:cNvSpPr txBox="1"/>
+          <p:nvPr/>
+        </p:nvSpPr>
+        <p:spPr>
+          <a:xfrm>
+            <a:off x="749808" y="1078992"/>
+            <a:ext cx="6492240" cy="3474720"/>
+          </a:xfrm>
+          <a:prstGeom prst="rect">
+            <a:avLst/>
+          </a:prstGeom>
+          <a:noFill/>
+        </p:spPr>
+        <p:txBody>
+          <a:bodyPr wrap="square">
+            <a:spAutoFit/>
+          </a:bodyPr>
+          <a:lstStyle/>
+          <a:p>
+            <a:pPr algn="l"/>
+            <a:r>
+              <a:rPr sz="1800">
+                <a:solidFill>
+                  <a:srgbClr val="17324D"/>
+                </a:solidFill>
+                <a:latin typeface="PingFang SC"/>
+              </a:rPr>
+              <a:t>先固化当前默认基线和本轮带趋势图的结果目录，避免后续实验覆盖。</a:t>
+            </a:r>
+          </a:p>
+          <a:p>
+            <a:pPr algn="l"/>
+            <a:r>
+              <a:rPr sz="1800">
+                <a:solidFill>
+                  <a:srgbClr val="17324D"/>
+                </a:solidFill>
+                <a:latin typeface="PingFang SC"/>
+              </a:rPr>
+              <a:t>围绕 idoff_a / isoff_a 做更聚焦的敏感度分析，识别真正主导 leakage 的参数组合。</a:t>
+            </a:r>
+          </a:p>
+          <a:p>
+            <a:pPr algn="l"/>
+            <a:r>
+              <a:rPr sz="1800">
+                <a:solidFill>
+                  <a:srgbClr val="17324D"/>
+                </a:solidFill>
+                <a:latin typeface="PingFang SC"/>
+              </a:rPr>
+              <a:t>优先增加 NSGA-II 和局部 refinement 预算，再判断是否需要更强的 refit 或特化优化器。</a:t>
+            </a:r>
+          </a:p>
+          <a:p>
+            <a:pPr algn="l"/>
+            <a:r>
+              <a:rPr sz="1800">
+                <a:solidFill>
+                  <a:srgbClr val="17324D"/>
+                </a:solidFill>
+                <a:latin typeface="PingFang SC"/>
+              </a:rPr>
+              <a:t>如果后续要评估非训练点泛化，再单独加强全局连续模型，而不是与训练点拟合问题混在一起。</a:t>
+            </a:r>
+          </a:p>
+        </p:txBody>
+      </p:sp>
+      <p:sp>
+        <p:nvSpPr>
+          <p:cNvPr id="5" name="Rounded Rectangle 4"/>
+          <p:cNvSpPr/>
+          <p:nvPr/>
+        </p:nvSpPr>
+        <p:spPr>
+          <a:xfrm>
+            <a:off x="786384" y="4919472"/>
+            <a:ext cx="3931920" cy="1188720"/>
+          </a:xfrm>
+          <a:prstGeom prst="roundRect">
+            <a:avLst/>
+          </a:prstGeom>
+          <a:solidFill>
+            <a:srgbClr val="FFFDFC"/>
+          </a:solidFill>
+          <a:ln w="27432">
+            <a:solidFill>
+              <a:srgbClr val="F3B33D"/>
+            </a:solidFill>
+          </a:ln>
+        </p:spPr>
+        <p:style>
+          <a:lnRef idx="1">
+            <a:schemeClr val="accent1"/>
+          </a:lnRef>
+          <a:fillRef idx="3">
+            <a:schemeClr val="accent1"/>
+          </a:fillRef>
+          <a:effectRef idx="2">
+            <a:schemeClr val="accent1"/>
+          </a:effectRef>
+          <a:fontRef idx="minor">
+            <a:schemeClr val="lt1"/>
+          </a:fontRef>
+        </p:style>
+        <p:txBody>
+          <a:bodyPr rtlCol="0" anchor="ctr"/>
+          <a:lstStyle/>
+          <a:p>
+            <a:pPr algn="ctr"/>
+          </a:p>
+        </p:txBody>
+      </p:sp>
+      <p:sp>
+        <p:nvSpPr>
+          <p:cNvPr id="6" name="TextBox 5"/>
+          <p:cNvSpPr txBox="1"/>
+          <p:nvPr/>
+        </p:nvSpPr>
+        <p:spPr>
+          <a:xfrm>
+            <a:off x="950976" y="5084064"/>
+            <a:ext cx="3602736" cy="320040"/>
+          </a:xfrm>
+          <a:prstGeom prst="rect">
+            <a:avLst/>
+          </a:prstGeom>
+          <a:noFill/>
+        </p:spPr>
+        <p:txBody>
+          <a:bodyPr wrap="square">
+            <a:spAutoFit/>
+          </a:bodyPr>
+          <a:lstStyle/>
+          <a:p>
+            <a:pPr algn="l"/>
+            <a:r>
+              <a:rPr sz="1600" b="1">
+                <a:solidFill>
+                  <a:srgbClr val="5C6B73"/>
+                </a:solidFill>
+                <a:latin typeface="PingFang SC"/>
+              </a:rPr>
+              <a:t>建议优先级</a:t>
+            </a:r>
+          </a:p>
+        </p:txBody>
+      </p:sp>
+      <p:sp>
+        <p:nvSpPr>
+          <p:cNvPr id="7" name="TextBox 6"/>
+          <p:cNvSpPr txBox="1"/>
+          <p:nvPr/>
+        </p:nvSpPr>
+        <p:spPr>
+          <a:xfrm>
+            <a:off x="950976" y="5431536"/>
+            <a:ext cx="3602736" cy="502920"/>
+          </a:xfrm>
+          <a:prstGeom prst="rect">
+            <a:avLst/>
+          </a:prstGeom>
+          <a:noFill/>
+        </p:spPr>
+        <p:txBody>
+          <a:bodyPr wrap="square">
+            <a:spAutoFit/>
+          </a:bodyPr>
+          <a:lstStyle/>
+          <a:p>
+            <a:pPr algn="l"/>
+            <a:r>
+              <a:rPr sz="2500" b="1">
+                <a:solidFill>
+                  <a:srgbClr val="17324D"/>
+                </a:solidFill>
+                <a:latin typeface="PingFang SC"/>
+              </a:rPr>
+              <a:t>预算提升 &gt; 漏电加权 &gt; 重写算法</a:t>
+            </a:r>
+          </a:p>
+        </p:txBody>
+      </p:sp>
+      <p:sp>
+        <p:nvSpPr>
+          <p:cNvPr id="8" name="TextBox 7"/>
+          <p:cNvSpPr txBox="1"/>
+          <p:nvPr/>
+        </p:nvSpPr>
+        <p:spPr>
+          <a:xfrm>
+            <a:off x="950976" y="5907024"/>
+            <a:ext cx="3602736" cy="54864"/>
+          </a:xfrm>
+          <a:prstGeom prst="rect">
+            <a:avLst/>
+          </a:prstGeom>
+          <a:noFill/>
+        </p:spPr>
+        <p:txBody>
+          <a:bodyPr wrap="square">
+            <a:spAutoFit/>
+          </a:bodyPr>
+          <a:lstStyle/>
+          <a:p>
+            <a:pPr algn="l"/>
+            <a:r>
+              <a:rPr sz="1100" b="0">
+                <a:solidFill>
+                  <a:srgbClr val="5C6B73"/>
+                </a:solidFill>
+                <a:latin typeface="PingFang SC"/>
+              </a:rPr>
+              <a:t>本轮实验已表明直接漏电加权会让 worst-case 变差。</a:t>
+            </a:r>
+          </a:p>
+        </p:txBody>
+      </p:sp>
+      <p:sp>
+        <p:nvSpPr>
+          <p:cNvPr id="9" name="Rounded Rectangle 8"/>
+          <p:cNvSpPr/>
+          <p:nvPr/>
+        </p:nvSpPr>
+        <p:spPr>
+          <a:xfrm>
+            <a:off x="7662672" y="1078992"/>
+            <a:ext cx="1883664" cy="2304288"/>
+          </a:xfrm>
+          <a:prstGeom prst="roundRect">
+            <a:avLst/>
+          </a:prstGeom>
+          <a:solidFill>
+            <a:srgbClr val="FFFDFC"/>
+          </a:solidFill>
+          <a:ln>
+            <a:solidFill>
+              <a:srgbClr val="D9CDB8"/>
+            </a:solidFill>
+          </a:ln>
+        </p:spPr>
+        <p:style>
+          <a:lnRef idx="1">
+            <a:schemeClr val="accent1"/>
+          </a:lnRef>
+          <a:fillRef idx="3">
+            <a:schemeClr val="accent1"/>
+          </a:fillRef>
+          <a:effectRef idx="2">
+            <a:schemeClr val="accent1"/>
+          </a:effectRef>
+          <a:fontRef idx="minor">
+            <a:schemeClr val="lt1"/>
+          </a:fontRef>
+        </p:style>
+        <p:txBody>
+          <a:bodyPr rtlCol="0" anchor="ctr"/>
+          <a:lstStyle/>
+          <a:p>
+            <a:pPr algn="ctr"/>
+          </a:p>
+        </p:txBody>
+      </p:sp>
+      <p:sp>
+        <p:nvSpPr>
+          <p:cNvPr id="10" name="TextBox 9"/>
+          <p:cNvSpPr txBox="1"/>
+          <p:nvPr/>
+        </p:nvSpPr>
+        <p:spPr>
+          <a:xfrm>
+            <a:off x="7827264" y="1170432"/>
+            <a:ext cx="1554480" cy="274320"/>
+          </a:xfrm>
+          <a:prstGeom prst="rect">
+            <a:avLst/>
+          </a:prstGeom>
+          <a:noFill/>
+        </p:spPr>
+        <p:txBody>
+          <a:bodyPr wrap="square">
+            <a:spAutoFit/>
+          </a:bodyPr>
+          <a:lstStyle/>
+          <a:p>
+            <a:pPr algn="l"/>
+            <a:r>
+              <a:rPr sz="1600" b="1">
+                <a:solidFill>
+                  <a:srgbClr val="17324D"/>
+                </a:solidFill>
+                <a:latin typeface="PingFang SC"/>
+              </a:rPr>
+              <a:t>vtsat heatmap</a:t>
+            </a:r>
+          </a:p>
+        </p:txBody>
+      </p:sp>
+      <p:pic>
+        <p:nvPicPr>
+          <p:cNvPr id="11" name="Picture 10" descr="error_heatmap_vtsat_v.png"/>
+          <p:cNvPicPr>
+            <a:picLocks noChangeAspect="1"/>
+          </p:cNvPicPr>
+          <p:nvPr/>
+        </p:nvPicPr>
+        <p:blipFill>
+          <a:blip r:embed="rId2"/>
+          <a:stretch>
+            <a:fillRect/>
+          </a:stretch>
+        </p:blipFill>
+        <p:spPr>
+          <a:xfrm>
+            <a:off x="7799832" y="1517904"/>
+            <a:ext cx="1609344" cy="1728216"/>
+          </a:xfrm>
+          <a:prstGeom prst="rect">
+            <a:avLst/>
+          </a:prstGeom>
+        </p:spPr>
+      </p:pic>
+      <p:sp>
+        <p:nvSpPr>
+          <p:cNvPr id="12" name="Rounded Rectangle 11"/>
+          <p:cNvSpPr/>
+          <p:nvPr/>
+        </p:nvSpPr>
+        <p:spPr>
+          <a:xfrm>
+            <a:off x="9637776" y="1078992"/>
+            <a:ext cx="1883664" cy="2304288"/>
+          </a:xfrm>
+          <a:prstGeom prst="roundRect">
+            <a:avLst/>
+          </a:prstGeom>
+          <a:solidFill>
+            <a:srgbClr val="FFFDFC"/>
+          </a:solidFill>
+          <a:ln>
+            <a:solidFill>
+              <a:srgbClr val="D9CDB8"/>
+            </a:solidFill>
+          </a:ln>
+        </p:spPr>
+        <p:style>
+          <a:lnRef idx="1">
+            <a:schemeClr val="accent1"/>
+          </a:lnRef>
+          <a:fillRef idx="3">
+            <a:schemeClr val="accent1"/>
+          </a:fillRef>
+          <a:effectRef idx="2">
+            <a:schemeClr val="accent1"/>
+          </a:effectRef>
+          <a:fontRef idx="minor">
+            <a:schemeClr val="lt1"/>
+          </a:fontRef>
+        </p:style>
+        <p:txBody>
+          <a:bodyPr rtlCol="0" anchor="ctr"/>
+          <a:lstStyle/>
+          <a:p>
+            <a:pPr algn="ctr"/>
+          </a:p>
+        </p:txBody>
+      </p:sp>
+      <p:sp>
+        <p:nvSpPr>
+          <p:cNvPr id="13" name="TextBox 12"/>
+          <p:cNvSpPr txBox="1"/>
+          <p:nvPr/>
+        </p:nvSpPr>
+        <p:spPr>
+          <a:xfrm>
+            <a:off x="9802367" y="1170432"/>
+            <a:ext cx="1554480" cy="274320"/>
+          </a:xfrm>
+          <a:prstGeom prst="rect">
+            <a:avLst/>
+          </a:prstGeom>
+          <a:noFill/>
+        </p:spPr>
+        <p:txBody>
+          <a:bodyPr wrap="square">
+            <a:spAutoFit/>
+          </a:bodyPr>
+          <a:lstStyle/>
+          <a:p>
+            <a:pPr algn="l"/>
+            <a:r>
+              <a:rPr sz="1600" b="1">
+                <a:solidFill>
+                  <a:srgbClr val="17324D"/>
+                </a:solidFill>
+                <a:latin typeface="PingFang SC"/>
+              </a:rPr>
+              <a:t>vtlin heatmap</a:t>
+            </a:r>
+          </a:p>
+        </p:txBody>
+      </p:sp>
+      <p:pic>
+        <p:nvPicPr>
+          <p:cNvPr id="14" name="Picture 13" descr="error_heatmap_vtlin_v.png"/>
+          <p:cNvPicPr>
+            <a:picLocks noChangeAspect="1"/>
+          </p:cNvPicPr>
+          <p:nvPr/>
+        </p:nvPicPr>
+        <p:blipFill>
+          <a:blip r:embed="rId3"/>
+          <a:stretch>
+            <a:fillRect/>
+          </a:stretch>
+        </p:blipFill>
+        <p:spPr>
+          <a:xfrm>
+            <a:off x="9774936" y="1517904"/>
+            <a:ext cx="1609344" cy="1728216"/>
+          </a:xfrm>
+          <a:prstGeom prst="rect">
+            <a:avLst/>
+          </a:prstGeom>
+        </p:spPr>
+      </p:pic>
+      <p:sp>
+        <p:nvSpPr>
+          <p:cNvPr id="15" name="Rounded Rectangle 14"/>
+          <p:cNvSpPr/>
+          <p:nvPr/>
+        </p:nvSpPr>
+        <p:spPr>
+          <a:xfrm>
+            <a:off x="7662672" y="3675887"/>
+            <a:ext cx="3858768" cy="2432304"/>
+          </a:xfrm>
+          <a:prstGeom prst="roundRect">
+            <a:avLst/>
+          </a:prstGeom>
+          <a:solidFill>
+            <a:srgbClr val="FFFDFC"/>
+          </a:solidFill>
+          <a:ln>
+            <a:solidFill>
+              <a:srgbClr val="D9CDB8"/>
+            </a:solidFill>
+          </a:ln>
+        </p:spPr>
+        <p:style>
+          <a:lnRef idx="1">
+            <a:schemeClr val="accent1"/>
+          </a:lnRef>
+          <a:fillRef idx="3">
+            <a:schemeClr val="accent1"/>
+          </a:fillRef>
+          <a:effectRef idx="2">
+            <a:schemeClr val="accent1"/>
+          </a:effectRef>
+          <a:fontRef idx="minor">
+            <a:schemeClr val="lt1"/>
+          </a:fontRef>
+        </p:style>
+        <p:txBody>
+          <a:bodyPr rtlCol="0" anchor="ctr"/>
+          <a:lstStyle/>
+          <a:p>
+            <a:pPr algn="ctr"/>
+          </a:p>
+        </p:txBody>
+      </p:sp>
+      <p:sp>
+        <p:nvSpPr>
+          <p:cNvPr id="16" name="TextBox 15"/>
+          <p:cNvSpPr txBox="1"/>
+          <p:nvPr/>
+        </p:nvSpPr>
+        <p:spPr>
+          <a:xfrm>
+            <a:off x="7827264" y="3767327"/>
+            <a:ext cx="3529584" cy="274320"/>
+          </a:xfrm>
+          <a:prstGeom prst="rect">
+            <a:avLst/>
+          </a:prstGeom>
+          <a:noFill/>
+        </p:spPr>
+        <p:txBody>
+          <a:bodyPr wrap="square">
+            <a:spAutoFit/>
+          </a:bodyPr>
+          <a:lstStyle/>
+          <a:p>
+            <a:pPr algn="l"/>
+            <a:r>
+              <a:rPr sz="1600" b="1">
+                <a:solidFill>
+                  <a:srgbClr val="17324D"/>
+                </a:solidFill>
+                <a:latin typeface="PingFang SC"/>
+              </a:rPr>
+              <a:t>pareto front</a:t>
+            </a:r>
+          </a:p>
+        </p:txBody>
+      </p:sp>
+      <p:pic>
+        <p:nvPicPr>
+          <p:cNvPr id="17" name="Picture 16" descr="pareto_front.png"/>
+          <p:cNvPicPr>
+            <a:picLocks noChangeAspect="1"/>
+          </p:cNvPicPr>
+          <p:nvPr/>
+        </p:nvPicPr>
+        <p:blipFill>
+          <a:blip r:embed="rId4"/>
+          <a:stretch>
+            <a:fillRect/>
+          </a:stretch>
+        </p:blipFill>
+        <p:spPr>
+          <a:xfrm>
+            <a:off x="7799832" y="4114800"/>
+            <a:ext cx="3584448" cy="1856232"/>
+          </a:xfrm>
+          <a:prstGeom prst="rect">
+            <a:avLst/>
+          </a:prstGeom>
+        </p:spPr>
+      </p:pic>
+    </p:spTree>
+  </p:cSld>
+  <p:clrMapOvr>
+    <a:masterClrMapping/>
+  </p:clrMapOvr>
+</p:sld>
+</file>
+
 <file path=ppt/slides/slide2.xml><?xml version="1.0" encoding="utf-8"?>
 <p:sld xmlns:a="http://schemas.openxmlformats.org/drawingml/2006/main" xmlns:p="http://schemas.openxmlformats.org/presentationml/2006/main" xmlns:r="http://schemas.openxmlformats.org/officeDocument/2006/relationships">
   <p:cSld>
@@ -4184,7 +4814,7 @@
                 </a:solidFill>
                 <a:latin typeface="PingFang SC"/>
               </a:rPr>
-              <a:t>2. 当前校准 pipeline</a:t>
+              <a:t>2. 整体技术方案</a:t>
             </a:r>
           </a:p>
         </p:txBody>
@@ -4197,8 +4827,8 @@
         </p:nvSpPr>
         <p:spPr>
           <a:xfrm>
-            <a:off x="749808" y="1042415"/>
-            <a:ext cx="4983480" cy="3200400"/>
+            <a:off x="749808" y="1024128"/>
+            <a:ext cx="5166360" cy="2999232"/>
           </a:xfrm>
           <a:prstGeom prst="rect">
             <a:avLst/>
@@ -4219,7 +4849,7 @@
                 </a:solidFill>
                 <a:latin typeface="PingFang SC"/>
               </a:rPr>
-              <a:t>目标数据按 W/L 尺寸索引，形成 42 个训练点。</a:t>
+              <a:t>输入层：读取 42 个 W/L 训练点目标数据，并基于参数边界定义可搜索空间。</a:t>
             </a:r>
           </a:p>
           <a:p>
@@ -4231,7 +4861,7 @@
                 </a:solidFill>
                 <a:latin typeface="PingFang SC"/>
               </a:rPr>
-              <a:t>4 角点多目标优化负责找出一组可行角点参数。</a:t>
+              <a:t>建模层：用 4 角点参数编码尺寸依赖，再通过双线性曲面把角点扩展到整个 W/L 域。</a:t>
             </a:r>
           </a:p>
           <a:p>
@@ -4243,7 +4873,7 @@
                 </a:solidFill>
                 <a:latin typeface="PingFang SC"/>
               </a:rPr>
-              <a:t>从角点构造连续参数曲面，为所有尺寸生成初始化参数。</a:t>
+              <a:t>优化层：先做 NSGA-II 多目标角点搜索，再做逐器件 bounded Powell + DE 局部微调。</a:t>
             </a:r>
           </a:p>
           <a:p>
@@ -4255,7 +4885,7 @@
                 </a:solidFill>
                 <a:latin typeface="PingFang SC"/>
               </a:rPr>
-              <a:t>逐器件进行 bounded Powell + DE 的局部精修，提升教师解质量。</a:t>
+              <a:t>泛化层：基于局部教师解执行全局 refit，形成可连续查询的参数曲面模型。</a:t>
             </a:r>
           </a:p>
           <a:p>
@@ -4267,7 +4897,7 @@
                 </a:solidFill>
                 <a:latin typeface="PingFang SC"/>
               </a:rPr>
-              <a:t>基于局部教师解重新拟合全局连续模型，输出 calibrated params / metrics / plots。</a:t>
+              <a:t>输出层：统一导出 params、metrics、error report、热图、趋势图和汇报材料。</a:t>
             </a:r>
           </a:p>
         </p:txBody>
@@ -4280,8 +4910,8 @@
         </p:nvSpPr>
         <p:spPr>
           <a:xfrm>
-            <a:off x="786384" y="4443984"/>
-            <a:ext cx="2670048" cy="1426464"/>
+            <a:off x="786384" y="4315968"/>
+            <a:ext cx="2615184" cy="1426464"/>
           </a:xfrm>
           <a:prstGeom prst="roundRect">
             <a:avLst/>
@@ -4325,8 +4955,8 @@
         </p:nvSpPr>
         <p:spPr>
           <a:xfrm>
-            <a:off x="950976" y="4608576"/>
-            <a:ext cx="2340864" cy="320040"/>
+            <a:off x="950976" y="4480559"/>
+            <a:ext cx="2286000" cy="320040"/>
           </a:xfrm>
           <a:prstGeom prst="rect">
             <a:avLst/>
@@ -4360,8 +4990,8 @@
         </p:nvSpPr>
         <p:spPr>
           <a:xfrm>
-            <a:off x="950976" y="4956048"/>
-            <a:ext cx="2340864" cy="502920"/>
+            <a:off x="950976" y="4828031"/>
+            <a:ext cx="2286000" cy="502920"/>
           </a:xfrm>
           <a:prstGeom prst="rect">
             <a:avLst/>
@@ -4395,8 +5025,8 @@
         </p:nvSpPr>
         <p:spPr>
           <a:xfrm>
-            <a:off x="950976" y="5431536"/>
-            <a:ext cx="2340864" cy="292608"/>
+            <a:off x="950976" y="5303520"/>
+            <a:ext cx="2286000" cy="292608"/>
           </a:xfrm>
           <a:prstGeom prst="rect">
             <a:avLst/>
@@ -4430,8 +5060,8 @@
         </p:nvSpPr>
         <p:spPr>
           <a:xfrm>
-            <a:off x="3639312" y="4443984"/>
-            <a:ext cx="2816352" cy="1426464"/>
+            <a:off x="3529584" y="4315968"/>
+            <a:ext cx="2615184" cy="1426464"/>
           </a:xfrm>
           <a:prstGeom prst="roundRect">
             <a:avLst/>
@@ -4475,8 +5105,8 @@
         </p:nvSpPr>
         <p:spPr>
           <a:xfrm>
-            <a:off x="3803904" y="4608576"/>
-            <a:ext cx="2487168" cy="320040"/>
+            <a:off x="3694176" y="4480559"/>
+            <a:ext cx="2286000" cy="320040"/>
           </a:xfrm>
           <a:prstGeom prst="rect">
             <a:avLst/>
@@ -4510,8 +5140,8 @@
         </p:nvSpPr>
         <p:spPr>
           <a:xfrm>
-            <a:off x="3803904" y="4956048"/>
-            <a:ext cx="2487168" cy="502920"/>
+            <a:off x="3694176" y="4828031"/>
+            <a:ext cx="2286000" cy="502920"/>
           </a:xfrm>
           <a:prstGeom prst="rect">
             <a:avLst/>
@@ -4545,8 +5175,8 @@
         </p:nvSpPr>
         <p:spPr>
           <a:xfrm>
-            <a:off x="3803904" y="5431536"/>
-            <a:ext cx="2487168" cy="292608"/>
+            <a:off x="3694176" y="5303520"/>
+            <a:ext cx="2286000" cy="292608"/>
           </a:xfrm>
           <a:prstGeom prst="rect">
             <a:avLst/>
@@ -4580,8 +5210,158 @@
         </p:nvSpPr>
         <p:spPr>
           <a:xfrm>
-            <a:off x="6711696" y="950976"/>
-            <a:ext cx="4828032" cy="5285232"/>
+            <a:off x="786384" y="5504688"/>
+            <a:ext cx="5358384" cy="914400"/>
+          </a:xfrm>
+          <a:prstGeom prst="roundRect">
+            <a:avLst/>
+          </a:prstGeom>
+          <a:solidFill>
+            <a:srgbClr val="FFFDFC"/>
+          </a:solidFill>
+          <a:ln w="27432">
+            <a:solidFill>
+              <a:srgbClr val="E07A5F"/>
+            </a:solidFill>
+          </a:ln>
+        </p:spPr>
+        <p:style>
+          <a:lnRef idx="1">
+            <a:schemeClr val="accent1"/>
+          </a:lnRef>
+          <a:fillRef idx="3">
+            <a:schemeClr val="accent1"/>
+          </a:fillRef>
+          <a:effectRef idx="2">
+            <a:schemeClr val="accent1"/>
+          </a:effectRef>
+          <a:fontRef idx="minor">
+            <a:schemeClr val="lt1"/>
+          </a:fontRef>
+        </p:style>
+        <p:txBody>
+          <a:bodyPr rtlCol="0" anchor="ctr"/>
+          <a:lstStyle/>
+          <a:p>
+            <a:pPr algn="ctr"/>
+          </a:p>
+        </p:txBody>
+      </p:sp>
+      <p:sp>
+        <p:nvSpPr>
+          <p:cNvPr id="14" name="TextBox 13"/>
+          <p:cNvSpPr txBox="1"/>
+          <p:nvPr/>
+        </p:nvSpPr>
+        <p:spPr>
+          <a:xfrm>
+            <a:off x="950976" y="5669279"/>
+            <a:ext cx="5029200" cy="320040"/>
+          </a:xfrm>
+          <a:prstGeom prst="rect">
+            <a:avLst/>
+          </a:prstGeom>
+          <a:noFill/>
+        </p:spPr>
+        <p:txBody>
+          <a:bodyPr wrap="square">
+            <a:spAutoFit/>
+          </a:bodyPr>
+          <a:lstStyle/>
+          <a:p>
+            <a:pPr algn="l"/>
+            <a:r>
+              <a:rPr sz="1600" b="1">
+                <a:solidFill>
+                  <a:srgbClr val="5C6B73"/>
+                </a:solidFill>
+                <a:latin typeface="PingFang SC"/>
+              </a:rPr>
+              <a:t>当前难点</a:t>
+            </a:r>
+          </a:p>
+        </p:txBody>
+      </p:sp>
+      <p:sp>
+        <p:nvSpPr>
+          <p:cNvPr id="15" name="TextBox 14"/>
+          <p:cNvSpPr txBox="1"/>
+          <p:nvPr/>
+        </p:nvSpPr>
+        <p:spPr>
+          <a:xfrm>
+            <a:off x="950976" y="6016752"/>
+            <a:ext cx="5029200" cy="502920"/>
+          </a:xfrm>
+          <a:prstGeom prst="rect">
+            <a:avLst/>
+          </a:prstGeom>
+          <a:noFill/>
+        </p:spPr>
+        <p:txBody>
+          <a:bodyPr wrap="square">
+            <a:spAutoFit/>
+          </a:bodyPr>
+          <a:lstStyle/>
+          <a:p>
+            <a:pPr algn="l"/>
+            <a:r>
+              <a:rPr sz="2500" b="1">
+                <a:solidFill>
+                  <a:srgbClr val="17324D"/>
+                </a:solidFill>
+                <a:latin typeface="PingFang SC"/>
+              </a:rPr>
+              <a:t>Leakage error 压降困难</a:t>
+            </a:r>
+          </a:p>
+        </p:txBody>
+      </p:sp>
+      <p:sp>
+        <p:nvSpPr>
+          <p:cNvPr id="16" name="TextBox 15"/>
+          <p:cNvSpPr txBox="1"/>
+          <p:nvPr/>
+        </p:nvSpPr>
+        <p:spPr>
+          <a:xfrm>
+            <a:off x="950976" y="6492240"/>
+            <a:ext cx="5029200" cy="-219456"/>
+          </a:xfrm>
+          <a:prstGeom prst="rect">
+            <a:avLst/>
+          </a:prstGeom>
+          <a:noFill/>
+        </p:spPr>
+        <p:txBody>
+          <a:bodyPr wrap="square">
+            <a:spAutoFit/>
+          </a:bodyPr>
+          <a:lstStyle/>
+          <a:p>
+            <a:pPr algn="l"/>
+            <a:r>
+              <a:rPr sz="1100" b="0">
+                <a:solidFill>
+                  <a:srgbClr val="5C6B73"/>
+                </a:solidFill>
+                <a:latin typeface="PingFang SC"/>
+              </a:rPr>
+              <a:t>目前最难收敛的仍是 idoff_a 和 isoff_a，说明需要更聚焦的参数敏感度与预算策略。</a:t>
+            </a:r>
+          </a:p>
+        </p:txBody>
+      </p:sp>
+      <p:sp>
+        <p:nvSpPr>
+          <p:cNvPr id="17" name="Rounded Rectangle 16"/>
+          <p:cNvSpPr/>
+          <p:nvPr/>
+        </p:nvSpPr>
+        <p:spPr>
+          <a:xfrm>
+            <a:off x="6729984" y="950976"/>
+            <a:ext cx="4791456" cy="5413248"/>
           </a:xfrm>
           <a:prstGeom prst="roundRect">
             <a:avLst/>
@@ -4619,14 +5399,14 @@
       </p:sp>
       <p:sp>
         <p:nvSpPr>
-          <p:cNvPr id="14" name="TextBox 13"/>
-          <p:cNvSpPr txBox="1"/>
-          <p:nvPr/>
-        </p:nvSpPr>
-        <p:spPr>
-          <a:xfrm>
-            <a:off x="6876288" y="1042416"/>
-            <a:ext cx="4498848" cy="274320"/>
+          <p:cNvPr id="18" name="TextBox 17"/>
+          <p:cNvSpPr txBox="1"/>
+          <p:nvPr/>
+        </p:nvSpPr>
+        <p:spPr>
+          <a:xfrm>
+            <a:off x="6894576" y="1042416"/>
+            <a:ext cx="4462272" cy="274320"/>
           </a:xfrm>
           <a:prstGeom prst="rect">
             <a:avLst/>
@@ -4647,14 +5427,14 @@
                 </a:solidFill>
                 <a:latin typeface="PingFang SC"/>
               </a:rPr>
-              <a:t>漏电误差热图</a:t>
+              <a:t>技术方案示意图</a:t>
             </a:r>
           </a:p>
         </p:txBody>
       </p:sp>
       <p:pic>
         <p:nvPicPr>
-          <p:cNvPr id="15" name="Picture 14" descr="error_heatmap_idoff_a.png"/>
+          <p:cNvPr id="19" name="Picture 18" descr="pareto_front.png"/>
           <p:cNvPicPr>
             <a:picLocks noChangeAspect="1"/>
           </p:cNvPicPr>
@@ -4668,8 +5448,8 @@
         </p:blipFill>
         <p:spPr>
           <a:xfrm>
-            <a:off x="6848856" y="1389888"/>
-            <a:ext cx="4553712" cy="4709160"/>
+            <a:off x="6867144" y="1389888"/>
+            <a:ext cx="4517136" cy="4837176"/>
           </a:xfrm>
           <a:prstGeom prst="rect">
             <a:avLst/>
@@ -4746,7 +5526,7 @@
         <p:spPr>
           <a:xfrm>
             <a:off x="658368" y="402336"/>
-            <a:ext cx="3657600" cy="438912"/>
+            <a:ext cx="3291840" cy="438912"/>
           </a:xfrm>
           <a:prstGeom prst="rect">
             <a:avLst/>
@@ -4767,7 +5547,7 @@
                 </a:solidFill>
                 <a:latin typeface="PingFang SC"/>
               </a:rPr>
-              <a:t>3. 工程化与验证状态</a:t>
+              <a:t>3. 代码规模统计</a:t>
             </a:r>
           </a:p>
         </p:txBody>
@@ -4780,8 +5560,8 @@
         </p:nvSpPr>
         <p:spPr>
           <a:xfrm>
-            <a:off x="749808" y="1078992"/>
-            <a:ext cx="2359152" cy="1353312"/>
+            <a:off x="749808" y="1024128"/>
+            <a:ext cx="2121408" cy="1353312"/>
           </a:xfrm>
           <a:prstGeom prst="roundRect">
             <a:avLst/>
@@ -4791,7 +5571,7 @@
           </a:solidFill>
           <a:ln w="27432">
             <a:solidFill>
-              <a:srgbClr val="2C7A4B"/>
+              <a:srgbClr val="F3B33D"/>
             </a:solidFill>
           </a:ln>
         </p:spPr>
@@ -4825,8 +5605,8 @@
         </p:nvSpPr>
         <p:spPr>
           <a:xfrm>
-            <a:off x="914400" y="1243584"/>
-            <a:ext cx="2029968" cy="320040"/>
+            <a:off x="914400" y="1188720"/>
+            <a:ext cx="1792224" cy="320040"/>
           </a:xfrm>
           <a:prstGeom prst="rect">
             <a:avLst/>
@@ -4847,7 +5627,7 @@
                 </a:solidFill>
                 <a:latin typeface="PingFang SC"/>
               </a:rPr>
-              <a:t>测试状态</a:t>
+              <a:t>总代码行数</a:t>
             </a:r>
           </a:p>
         </p:txBody>
@@ -4860,8 +5640,8 @@
         </p:nvSpPr>
         <p:spPr>
           <a:xfrm>
-            <a:off x="914400" y="1591056"/>
-            <a:ext cx="2029968" cy="502920"/>
+            <a:off x="914400" y="1536192"/>
+            <a:ext cx="1792224" cy="502920"/>
           </a:xfrm>
           <a:prstGeom prst="rect">
             <a:avLst/>
@@ -4882,7 +5662,7 @@
                 </a:solidFill>
                 <a:latin typeface="PingFang SC"/>
               </a:rPr>
-              <a:t>40 / 40 通过</a:t>
+              <a:t>3086</a:t>
             </a:r>
           </a:p>
         </p:txBody>
@@ -4895,8 +5675,8 @@
         </p:nvSpPr>
         <p:spPr>
           <a:xfrm>
-            <a:off x="914400" y="2066543"/>
-            <a:ext cx="2029968" cy="219456"/>
+            <a:off x="914400" y="2011680"/>
+            <a:ext cx="1792224" cy="219456"/>
           </a:xfrm>
           <a:prstGeom prst="rect">
             <a:avLst/>
@@ -4917,7 +5697,7 @@
                 </a:solidFill>
                 <a:latin typeface="PingFang SC"/>
               </a:rPr>
-              <a:t>仓库已验证从数学层测试到 PySpice-backed smoke test 的完整链路。</a:t>
+              <a:t>按 `src/`、`scripts/`、`tests/` 下全部 `.py` 文件统计。</a:t>
             </a:r>
           </a:p>
         </p:txBody>
@@ -4930,8 +5710,8 @@
         </p:nvSpPr>
         <p:spPr>
           <a:xfrm>
-            <a:off x="3310128" y="1078992"/>
-            <a:ext cx="2286000" cy="1353312"/>
+            <a:off x="3090672" y="1024128"/>
+            <a:ext cx="2121408" cy="1353312"/>
           </a:xfrm>
           <a:prstGeom prst="roundRect">
             <a:avLst/>
@@ -4975,8 +5755,8 @@
         </p:nvSpPr>
         <p:spPr>
           <a:xfrm>
-            <a:off x="3474720" y="1243584"/>
-            <a:ext cx="1956816" cy="320040"/>
+            <a:off x="3255264" y="1188720"/>
+            <a:ext cx="1792224" cy="320040"/>
           </a:xfrm>
           <a:prstGeom prst="rect">
             <a:avLst/>
@@ -4997,7 +5777,7 @@
                 </a:solidFill>
                 <a:latin typeface="PingFang SC"/>
               </a:rPr>
-              <a:t>输出闭环</a:t>
+              <a:t>Python 文件数</a:t>
             </a:r>
           </a:p>
         </p:txBody>
@@ -5010,8 +5790,8 @@
         </p:nvSpPr>
         <p:spPr>
           <a:xfrm>
-            <a:off x="3474720" y="1591056"/>
-            <a:ext cx="1956816" cy="502920"/>
+            <a:off x="3255264" y="1536192"/>
+            <a:ext cx="1792224" cy="502920"/>
           </a:xfrm>
           <a:prstGeom prst="rect">
             <a:avLst/>
@@ -5032,7 +5812,7 @@
                 </a:solidFill>
                 <a:latin typeface="PingFang SC"/>
               </a:rPr>
-              <a:t>CSV + Markdown + PNG</a:t>
+              <a:t>33</a:t>
             </a:r>
           </a:p>
         </p:txBody>
@@ -5045,8 +5825,8 @@
         </p:nvSpPr>
         <p:spPr>
           <a:xfrm>
-            <a:off x="3474720" y="2066543"/>
-            <a:ext cx="1956816" cy="219456"/>
+            <a:off x="3255264" y="2011680"/>
+            <a:ext cx="1792224" cy="219456"/>
           </a:xfrm>
           <a:prstGeom prst="rect">
             <a:avLst/>
@@ -5067,7 +5847,7 @@
                 </a:solidFill>
                 <a:latin typeface="PingFang SC"/>
               </a:rPr>
-              <a:t>历史上已生成 calibration_output 与 dataset_generation 两类产物。</a:t>
+              <a:t>当前项目主要逻辑、入口和测试都已经模块化整理。</a:t>
             </a:r>
           </a:p>
         </p:txBody>
@@ -5080,8 +5860,8 @@
         </p:nvSpPr>
         <p:spPr>
           <a:xfrm>
-            <a:off x="5797296" y="1078992"/>
-            <a:ext cx="2871216" cy="1353312"/>
+            <a:off x="5431536" y="1024128"/>
+            <a:ext cx="2779776" cy="1353312"/>
           </a:xfrm>
           <a:prstGeom prst="roundRect">
             <a:avLst/>
@@ -5091,7 +5871,7 @@
           </a:solidFill>
           <a:ln w="27432">
             <a:solidFill>
-              <a:srgbClr val="F3B33D"/>
+              <a:srgbClr val="E07A5F"/>
             </a:solidFill>
           </a:ln>
         </p:spPr>
@@ -5125,8 +5905,8 @@
         </p:nvSpPr>
         <p:spPr>
           <a:xfrm>
-            <a:off x="5961888" y="1243584"/>
-            <a:ext cx="2542032" cy="320040"/>
+            <a:off x="5596128" y="1188720"/>
+            <a:ext cx="2450592" cy="320040"/>
           </a:xfrm>
           <a:prstGeom prst="rect">
             <a:avLst/>
@@ -5147,7 +5927,7 @@
                 </a:solidFill>
                 <a:latin typeface="PingFang SC"/>
               </a:rPr>
-              <a:t>运行入口</a:t>
+              <a:t>最大模块</a:t>
             </a:r>
           </a:p>
         </p:txBody>
@@ -5160,8 +5940,8 @@
         </p:nvSpPr>
         <p:spPr>
           <a:xfrm>
-            <a:off x="5961888" y="1591056"/>
-            <a:ext cx="2542032" cy="502920"/>
+            <a:off x="5596128" y="1536192"/>
+            <a:ext cx="2450592" cy="502920"/>
           </a:xfrm>
           <a:prstGeom prst="rect">
             <a:avLst/>
@@ -5182,7 +5962,7 @@
                 </a:solidFill>
                 <a:latin typeface="PingFang SC"/>
               </a:rPr>
-              <a:t>scripts/run_calibration.py</a:t>
+              <a:t>src/optimizer.py</a:t>
             </a:r>
           </a:p>
         </p:txBody>
@@ -5195,8 +5975,8 @@
         </p:nvSpPr>
         <p:spPr>
           <a:xfrm>
-            <a:off x="5961888" y="2066543"/>
-            <a:ext cx="2542032" cy="219456"/>
+            <a:off x="5596128" y="2011680"/>
+            <a:ext cx="2450592" cy="219456"/>
           </a:xfrm>
           <a:prstGeom prst="rect">
             <a:avLst/>
@@ -5217,80 +5997,21 @@
                 </a:solidFill>
                 <a:latin typeface="PingFang SC"/>
               </a:rPr>
-              <a:t>建议继续使用 scripts/ 下标准入口，而不是兼容 wrapper。</a:t>
-            </a:r>
-          </a:p>
-        </p:txBody>
-      </p:sp>
-      <p:sp>
-        <p:nvSpPr>
-          <p:cNvPr id="16" name="TextBox 15"/>
-          <p:cNvSpPr txBox="1"/>
-          <p:nvPr/>
-        </p:nvSpPr>
-        <p:spPr>
-          <a:xfrm>
-            <a:off x="768096" y="2788920"/>
-            <a:ext cx="5230368" cy="2011680"/>
-          </a:xfrm>
-          <a:prstGeom prst="rect">
-            <a:avLst/>
-          </a:prstGeom>
-          <a:noFill/>
-        </p:spPr>
-        <p:txBody>
-          <a:bodyPr wrap="square">
-            <a:spAutoFit/>
-          </a:bodyPr>
-          <a:lstStyle/>
-          <a:p>
-            <a:pPr algn="l"/>
-            <a:r>
-              <a:rPr sz="1800">
-                <a:solidFill>
-                  <a:srgbClr val="17324D"/>
-                </a:solidFill>
-                <a:latin typeface="PingFang SC"/>
-              </a:rPr>
-              <a:t>当前 `spice` 环境已能跑通全量测试和真实仿真 smoke test。</a:t>
-            </a:r>
-          </a:p>
-          <a:p>
-            <a:pPr algn="l"/>
-            <a:r>
-              <a:rPr sz="1800">
-                <a:solidFill>
-                  <a:srgbClr val="17324D"/>
-                </a:solidFill>
-                <a:latin typeface="PingFang SC"/>
-              </a:rPr>
-              <a:t>新增趋势图与 PPT builder 后，校准结果和汇报材料都能跟随同一套输出目录更新。</a:t>
-            </a:r>
-          </a:p>
-          <a:p>
-            <a:pPr algn="l"/>
-            <a:r>
-              <a:rPr sz="1800">
-                <a:solidFill>
-                  <a:srgbClr val="17324D"/>
-                </a:solidFill>
-                <a:latin typeface="PingFang SC"/>
-              </a:rPr>
-              <a:t>本轮新增产物重点补上了参数随 W/L 变化的趋势视图，方便检查曲面形状是否符合预期。</a:t>
-            </a:r>
-          </a:p>
-        </p:txBody>
-      </p:sp>
-      <p:sp>
-        <p:nvSpPr>
-          <p:cNvPr id="17" name="Rounded Rectangle 16"/>
+              <a:t>当前行数最多的文件，承载端到端编排和多阶段校准主流程。</a:t>
+            </a:r>
+          </a:p>
+        </p:txBody>
+      </p:sp>
+      <p:sp>
+        <p:nvSpPr>
+          <p:cNvPr id="16" name="Rounded Rectangle 15"/>
           <p:cNvSpPr/>
           <p:nvPr/>
         </p:nvSpPr>
         <p:spPr>
           <a:xfrm>
-            <a:off x="6309360" y="1920240"/>
-            <a:ext cx="5212080" cy="4434840"/>
+            <a:off x="749808" y="2761488"/>
+            <a:ext cx="4059936" cy="2011680"/>
           </a:xfrm>
           <a:prstGeom prst="roundRect">
             <a:avLst/>
@@ -5328,14 +6049,199 @@
       </p:sp>
       <p:sp>
         <p:nvSpPr>
+          <p:cNvPr id="17" name="TextBox 16"/>
+          <p:cNvSpPr txBox="1"/>
+          <p:nvPr/>
+        </p:nvSpPr>
+        <p:spPr>
+          <a:xfrm>
+            <a:off x="914400" y="2871216"/>
+            <a:ext cx="3730752" cy="274320"/>
+          </a:xfrm>
+          <a:prstGeom prst="rect">
+            <a:avLst/>
+          </a:prstGeom>
+          <a:noFill/>
+        </p:spPr>
+        <p:txBody>
+          <a:bodyPr wrap="square">
+            <a:spAutoFit/>
+          </a:bodyPr>
+          <a:lstStyle/>
+          <a:p>
+            <a:pPr algn="l"/>
+            <a:r>
+              <a:rPr sz="1600" b="1">
+                <a:solidFill>
+                  <a:srgbClr val="17324D"/>
+                </a:solidFill>
+                <a:latin typeface="PingFang SC"/>
+              </a:rPr>
+              <a:t>目录级统计</a:t>
+            </a:r>
+          </a:p>
+        </p:txBody>
+      </p:sp>
+      <p:sp>
+        <p:nvSpPr>
           <p:cNvPr id="18" name="TextBox 17"/>
           <p:cNvSpPr txBox="1"/>
           <p:nvPr/>
         </p:nvSpPr>
         <p:spPr>
           <a:xfrm>
-            <a:off x="6473952" y="2011680"/>
-            <a:ext cx="4882896" cy="274320"/>
+            <a:off x="950976" y="3273552"/>
+            <a:ext cx="3657600" cy="329184"/>
+          </a:xfrm>
+          <a:prstGeom prst="rect">
+            <a:avLst/>
+          </a:prstGeom>
+          <a:noFill/>
+        </p:spPr>
+        <p:txBody>
+          <a:bodyPr wrap="square">
+            <a:spAutoFit/>
+          </a:bodyPr>
+          <a:lstStyle/>
+          <a:p>
+            <a:pPr algn="l"/>
+            <a:r>
+              <a:rPr sz="1300" b="0">
+                <a:solidFill>
+                  <a:srgbClr val="17324D"/>
+                </a:solidFill>
+                <a:latin typeface="Menlo"/>
+              </a:rPr>
+              <a:t>src      files=17  lines=1840</a:t>
+            </a:r>
+          </a:p>
+        </p:txBody>
+      </p:sp>
+      <p:sp>
+        <p:nvSpPr>
+          <p:cNvPr id="19" name="TextBox 18"/>
+          <p:cNvSpPr txBox="1"/>
+          <p:nvPr/>
+        </p:nvSpPr>
+        <p:spPr>
+          <a:xfrm>
+            <a:off x="950976" y="3657600"/>
+            <a:ext cx="3657600" cy="329184"/>
+          </a:xfrm>
+          <a:prstGeom prst="rect">
+            <a:avLst/>
+          </a:prstGeom>
+          <a:noFill/>
+        </p:spPr>
+        <p:txBody>
+          <a:bodyPr wrap="square">
+            <a:spAutoFit/>
+          </a:bodyPr>
+          <a:lstStyle/>
+          <a:p>
+            <a:pPr algn="l"/>
+            <a:r>
+              <a:rPr sz="1300" b="0">
+                <a:solidFill>
+                  <a:srgbClr val="17324D"/>
+                </a:solidFill>
+                <a:latin typeface="Menlo"/>
+              </a:rPr>
+              <a:t>scripts  files= 3  lines= 482</a:t>
+            </a:r>
+          </a:p>
+        </p:txBody>
+      </p:sp>
+      <p:sp>
+        <p:nvSpPr>
+          <p:cNvPr id="20" name="TextBox 19"/>
+          <p:cNvSpPr txBox="1"/>
+          <p:nvPr/>
+        </p:nvSpPr>
+        <p:spPr>
+          <a:xfrm>
+            <a:off x="950976" y="4041648"/>
+            <a:ext cx="3657600" cy="329184"/>
+          </a:xfrm>
+          <a:prstGeom prst="rect">
+            <a:avLst/>
+          </a:prstGeom>
+          <a:noFill/>
+        </p:spPr>
+        <p:txBody>
+          <a:bodyPr wrap="square">
+            <a:spAutoFit/>
+          </a:bodyPr>
+          <a:lstStyle/>
+          <a:p>
+            <a:pPr algn="l"/>
+            <a:r>
+              <a:rPr sz="1300" b="0">
+                <a:solidFill>
+                  <a:srgbClr val="17324D"/>
+                </a:solidFill>
+                <a:latin typeface="Menlo"/>
+              </a:rPr>
+              <a:t>tests    files=13  lines= 764</a:t>
+            </a:r>
+          </a:p>
+        </p:txBody>
+      </p:sp>
+      <p:sp>
+        <p:nvSpPr>
+          <p:cNvPr id="21" name="Rounded Rectangle 20"/>
+          <p:cNvSpPr/>
+          <p:nvPr/>
+        </p:nvSpPr>
+        <p:spPr>
+          <a:xfrm>
+            <a:off x="5010912" y="2761488"/>
+            <a:ext cx="3803904" cy="3072384"/>
+          </a:xfrm>
+          <a:prstGeom prst="roundRect">
+            <a:avLst/>
+          </a:prstGeom>
+          <a:solidFill>
+            <a:srgbClr val="FFFDFC"/>
+          </a:solidFill>
+          <a:ln>
+            <a:solidFill>
+              <a:srgbClr val="D9CDB8"/>
+            </a:solidFill>
+          </a:ln>
+        </p:spPr>
+        <p:style>
+          <a:lnRef idx="1">
+            <a:schemeClr val="accent1"/>
+          </a:lnRef>
+          <a:fillRef idx="3">
+            <a:schemeClr val="accent1"/>
+          </a:fillRef>
+          <a:effectRef idx="2">
+            <a:schemeClr val="accent1"/>
+          </a:effectRef>
+          <a:fontRef idx="minor">
+            <a:schemeClr val="lt1"/>
+          </a:fontRef>
+        </p:style>
+        <p:txBody>
+          <a:bodyPr rtlCol="0" anchor="ctr"/>
+          <a:lstStyle/>
+          <a:p>
+            <a:pPr algn="ctr"/>
+          </a:p>
+        </p:txBody>
+      </p:sp>
+      <p:sp>
+        <p:nvSpPr>
+          <p:cNvPr id="22" name="TextBox 21"/>
+          <p:cNvSpPr txBox="1"/>
+          <p:nvPr/>
+        </p:nvSpPr>
+        <p:spPr>
+          <a:xfrm>
+            <a:off x="5175504" y="2871216"/>
+            <a:ext cx="3474720" cy="274320"/>
           </a:xfrm>
           <a:prstGeom prst="rect">
             <a:avLst/>
@@ -5356,35 +6262,268 @@
                 </a:solidFill>
                 <a:latin typeface="PingFang SC"/>
               </a:rPr>
-              <a:t>参数随 L 变化</a:t>
-            </a:r>
-          </a:p>
-        </p:txBody>
-      </p:sp>
-      <p:pic>
-        <p:nvPicPr>
-          <p:cNvPr id="19" name="Picture 18" descr="parameter_trends_vs_l.png"/>
-          <p:cNvPicPr>
-            <a:picLocks noChangeAspect="1"/>
-          </p:cNvPicPr>
-          <p:nvPr/>
-        </p:nvPicPr>
-        <p:blipFill>
-          <a:blip r:embed="rId2"/>
-          <a:stretch>
-            <a:fillRect/>
-          </a:stretch>
-        </p:blipFill>
-        <p:spPr>
-          <a:xfrm>
-            <a:off x="6446520" y="2359152"/>
-            <a:ext cx="4937760" cy="3858768"/>
-          </a:xfrm>
-          <a:prstGeom prst="rect">
-            <a:avLst/>
-          </a:prstGeom>
-        </p:spPr>
-      </p:pic>
+              <a:t>Top 文件行数</a:t>
+            </a:r>
+          </a:p>
+        </p:txBody>
+      </p:sp>
+      <p:sp>
+        <p:nvSpPr>
+          <p:cNvPr id="23" name="TextBox 22"/>
+          <p:cNvSpPr txBox="1"/>
+          <p:nvPr/>
+        </p:nvSpPr>
+        <p:spPr>
+          <a:xfrm>
+            <a:off x="5212080" y="3273552"/>
+            <a:ext cx="3401568" cy="329184"/>
+          </a:xfrm>
+          <a:prstGeom prst="rect">
+            <a:avLst/>
+          </a:prstGeom>
+          <a:noFill/>
+        </p:spPr>
+        <p:txBody>
+          <a:bodyPr wrap="square">
+            <a:spAutoFit/>
+          </a:bodyPr>
+          <a:lstStyle/>
+          <a:p>
+            <a:pPr algn="l"/>
+            <a:r>
+              <a:rPr sz="1300" b="0">
+                <a:solidFill>
+                  <a:srgbClr val="17324D"/>
+                </a:solidFill>
+                <a:latin typeface="Menlo"/>
+              </a:rPr>
+              <a:t> 748  src/optimizer.py</a:t>
+            </a:r>
+          </a:p>
+        </p:txBody>
+      </p:sp>
+      <p:sp>
+        <p:nvSpPr>
+          <p:cNvPr id="24" name="TextBox 23"/>
+          <p:cNvSpPr txBox="1"/>
+          <p:nvPr/>
+        </p:nvSpPr>
+        <p:spPr>
+          <a:xfrm>
+            <a:off x="5212080" y="3657600"/>
+            <a:ext cx="3401568" cy="329184"/>
+          </a:xfrm>
+          <a:prstGeom prst="rect">
+            <a:avLst/>
+          </a:prstGeom>
+          <a:noFill/>
+        </p:spPr>
+        <p:txBody>
+          <a:bodyPr wrap="square">
+            <a:spAutoFit/>
+          </a:bodyPr>
+          <a:lstStyle/>
+          <a:p>
+            <a:pPr algn="l"/>
+            <a:r>
+              <a:rPr sz="1300" b="0">
+                <a:solidFill>
+                  <a:srgbClr val="17324D"/>
+                </a:solidFill>
+                <a:latin typeface="Menlo"/>
+              </a:rPr>
+              <a:t> 454  scripts/build_progress_ppt.py</a:t>
+            </a:r>
+          </a:p>
+        </p:txBody>
+      </p:sp>
+      <p:sp>
+        <p:nvSpPr>
+          <p:cNvPr id="25" name="TextBox 24"/>
+          <p:cNvSpPr txBox="1"/>
+          <p:nvPr/>
+        </p:nvSpPr>
+        <p:spPr>
+          <a:xfrm>
+            <a:off x="5212080" y="4041648"/>
+            <a:ext cx="3401568" cy="329184"/>
+          </a:xfrm>
+          <a:prstGeom prst="rect">
+            <a:avLst/>
+          </a:prstGeom>
+          <a:noFill/>
+        </p:spPr>
+        <p:txBody>
+          <a:bodyPr wrap="square">
+            <a:spAutoFit/>
+          </a:bodyPr>
+          <a:lstStyle/>
+          <a:p>
+            <a:pPr algn="l"/>
+            <a:r>
+              <a:rPr sz="1300" b="0">
+                <a:solidFill>
+                  <a:srgbClr val="17324D"/>
+                </a:solidFill>
+                <a:latin typeface="Menlo"/>
+              </a:rPr>
+              <a:t> 322  src/dataset_generator.py</a:t>
+            </a:r>
+          </a:p>
+        </p:txBody>
+      </p:sp>
+      <p:sp>
+        <p:nvSpPr>
+          <p:cNvPr id="26" name="TextBox 25"/>
+          <p:cNvSpPr txBox="1"/>
+          <p:nvPr/>
+        </p:nvSpPr>
+        <p:spPr>
+          <a:xfrm>
+            <a:off x="5212080" y="4425696"/>
+            <a:ext cx="3401568" cy="329184"/>
+          </a:xfrm>
+          <a:prstGeom prst="rect">
+            <a:avLst/>
+          </a:prstGeom>
+          <a:noFill/>
+        </p:spPr>
+        <p:txBody>
+          <a:bodyPr wrap="square">
+            <a:spAutoFit/>
+          </a:bodyPr>
+          <a:lstStyle/>
+          <a:p>
+            <a:pPr algn="l"/>
+            <a:r>
+              <a:rPr sz="1300" b="0">
+                <a:solidFill>
+                  <a:srgbClr val="17324D"/>
+                </a:solidFill>
+                <a:latin typeface="Menlo"/>
+              </a:rPr>
+              <a:t> 221  tests/test_optimizer_corner_nsga.py</a:t>
+            </a:r>
+          </a:p>
+        </p:txBody>
+      </p:sp>
+      <p:sp>
+        <p:nvSpPr>
+          <p:cNvPr id="27" name="TextBox 26"/>
+          <p:cNvSpPr txBox="1"/>
+          <p:nvPr/>
+        </p:nvSpPr>
+        <p:spPr>
+          <a:xfrm>
+            <a:off x="5212080" y="4809744"/>
+            <a:ext cx="3401568" cy="329184"/>
+          </a:xfrm>
+          <a:prstGeom prst="rect">
+            <a:avLst/>
+          </a:prstGeom>
+          <a:noFill/>
+        </p:spPr>
+        <p:txBody>
+          <a:bodyPr wrap="square">
+            <a:spAutoFit/>
+          </a:bodyPr>
+          <a:lstStyle/>
+          <a:p>
+            <a:pPr algn="l"/>
+            <a:r>
+              <a:rPr sz="1300" b="0">
+                <a:solidFill>
+                  <a:srgbClr val="17324D"/>
+                </a:solidFill>
+                <a:latin typeface="Menlo"/>
+              </a:rPr>
+              <a:t> 173  src/plotting.py</a:t>
+            </a:r>
+          </a:p>
+        </p:txBody>
+      </p:sp>
+      <p:sp>
+        <p:nvSpPr>
+          <p:cNvPr id="28" name="TextBox 27"/>
+          <p:cNvSpPr txBox="1"/>
+          <p:nvPr/>
+        </p:nvSpPr>
+        <p:spPr>
+          <a:xfrm>
+            <a:off x="5212080" y="5193792"/>
+            <a:ext cx="3401568" cy="329184"/>
+          </a:xfrm>
+          <a:prstGeom prst="rect">
+            <a:avLst/>
+          </a:prstGeom>
+          <a:noFill/>
+        </p:spPr>
+        <p:txBody>
+          <a:bodyPr wrap="square">
+            <a:spAutoFit/>
+          </a:bodyPr>
+          <a:lstStyle/>
+          <a:p>
+            <a:pPr algn="l"/>
+            <a:r>
+              <a:rPr sz="1300" b="0">
+                <a:solidFill>
+                  <a:srgbClr val="17324D"/>
+                </a:solidFill>
+                <a:latin typeface="Menlo"/>
+              </a:rPr>
+              <a:t> 144  tests/test_plotting.py</a:t>
+            </a:r>
+          </a:p>
+        </p:txBody>
+      </p:sp>
+      <p:sp>
+        <p:nvSpPr>
+          <p:cNvPr id="29" name="TextBox 28"/>
+          <p:cNvSpPr txBox="1"/>
+          <p:nvPr/>
+        </p:nvSpPr>
+        <p:spPr>
+          <a:xfrm>
+            <a:off x="9034272" y="2816352"/>
+            <a:ext cx="2395728" cy="2651760"/>
+          </a:xfrm>
+          <a:prstGeom prst="rect">
+            <a:avLst/>
+          </a:prstGeom>
+          <a:noFill/>
+        </p:spPr>
+        <p:txBody>
+          <a:bodyPr wrap="square">
+            <a:spAutoFit/>
+          </a:bodyPr>
+          <a:lstStyle/>
+          <a:p>
+            <a:pPr algn="l"/>
+            <a:r>
+              <a:rPr sz="1400">
+                <a:solidFill>
+                  <a:srgbClr val="17324D"/>
+                </a:solidFill>
+                <a:latin typeface="PingFang SC"/>
+              </a:rPr>
+              <a:t>当前代码量以 `src/` 为主，说明核心复杂度集中在校准、建模和报告生成链路。</a:t>
+            </a:r>
+          </a:p>
+          <a:p>
+            <a:pPr algn="l"/>
+            <a:r>
+              <a:rPr sz="1400">
+                <a:solidFill>
+                  <a:srgbClr val="17324D"/>
+                </a:solidFill>
+                <a:latin typeface="PingFang SC"/>
+              </a:rPr>
+              <a:t>测试代码约占总量的四分之一，说明工程已经具备较好的可验证性基础。</a:t>
+            </a:r>
+          </a:p>
+        </p:txBody>
+      </p:sp>
     </p:spTree>
   </p:cSld>
   <p:clrMapOvr>
@@ -5455,7 +6594,7 @@
         <p:spPr>
           <a:xfrm>
             <a:off x="658368" y="402336"/>
-            <a:ext cx="3200400" cy="438912"/>
+            <a:ext cx="3657600" cy="438912"/>
           </a:xfrm>
           <a:prstGeom prst="rect">
             <a:avLst/>
@@ -5476,7 +6615,7 @@
                 </a:solidFill>
                 <a:latin typeface="PingFang SC"/>
               </a:rPr>
-              <a:t>4. 当前结果总览</a:t>
+              <a:t>4. 工程化与验证状态</a:t>
             </a:r>
           </a:p>
         </p:txBody>
@@ -5489,8 +6628,8 @@
         </p:nvSpPr>
         <p:spPr>
           <a:xfrm>
-            <a:off x="749808" y="1042415"/>
-            <a:ext cx="2212848" cy="1325880"/>
+            <a:off x="749808" y="1078992"/>
+            <a:ext cx="2359152" cy="1353312"/>
           </a:xfrm>
           <a:prstGeom prst="roundRect">
             <a:avLst/>
@@ -5500,7 +6639,7 @@
           </a:solidFill>
           <a:ln w="27432">
             <a:solidFill>
-              <a:srgbClr val="AA5B10"/>
+              <a:srgbClr val="2C7A4B"/>
             </a:solidFill>
           </a:ln>
         </p:spPr>
@@ -5534,8 +6673,8 @@
         </p:nvSpPr>
         <p:spPr>
           <a:xfrm>
-            <a:off x="914400" y="1207007"/>
-            <a:ext cx="1883664" cy="320040"/>
+            <a:off x="914400" y="1243584"/>
+            <a:ext cx="2029968" cy="320040"/>
           </a:xfrm>
           <a:prstGeom prst="rect">
             <a:avLst/>
@@ -5556,7 +6695,7 @@
                 </a:solidFill>
                 <a:latin typeface="PingFang SC"/>
               </a:rPr>
-              <a:t>worst-case</a:t>
+              <a:t>测试状态</a:t>
             </a:r>
           </a:p>
         </p:txBody>
@@ -5569,8 +6708,8 @@
         </p:nvSpPr>
         <p:spPr>
           <a:xfrm>
-            <a:off x="914400" y="1554480"/>
-            <a:ext cx="1883664" cy="502920"/>
+            <a:off x="914400" y="1591056"/>
+            <a:ext cx="2029968" cy="502920"/>
           </a:xfrm>
           <a:prstGeom prst="rect">
             <a:avLst/>
@@ -5591,7 +6730,7 @@
                 </a:solidFill>
                 <a:latin typeface="PingFang SC"/>
               </a:rPr>
-              <a:t>5.10%</a:t>
+              <a:t>40 / 40 通过</a:t>
             </a:r>
           </a:p>
         </p:txBody>
@@ -5604,8 +6743,8 @@
         </p:nvSpPr>
         <p:spPr>
           <a:xfrm>
-            <a:off x="914400" y="2029967"/>
-            <a:ext cx="1883664" cy="192023"/>
+            <a:off x="914400" y="2066543"/>
+            <a:ext cx="2029968" cy="219456"/>
           </a:xfrm>
           <a:prstGeom prst="rect">
             <a:avLst/>
@@ -5626,7 +6765,7 @@
                 </a:solidFill>
                 <a:latin typeface="PingFang SC"/>
               </a:rPr>
-              <a:t>当前默认结果仍高于 3% 验收目标。</a:t>
+              <a:t>仓库已验证从数学层测试到 PySpice-backed smoke test 的完整链路。</a:t>
             </a:r>
           </a:p>
         </p:txBody>
@@ -5639,158 +6778,8 @@
         </p:nvSpPr>
         <p:spPr>
           <a:xfrm>
-            <a:off x="3182112" y="1042415"/>
-            <a:ext cx="2578608" cy="1325880"/>
-          </a:xfrm>
-          <a:prstGeom prst="roundRect">
-            <a:avLst/>
-          </a:prstGeom>
-          <a:solidFill>
-            <a:srgbClr val="FFFDFC"/>
-          </a:solidFill>
-          <a:ln w="27432">
-            <a:solidFill>
-              <a:srgbClr val="E07A5F"/>
-            </a:solidFill>
-          </a:ln>
-        </p:spPr>
-        <p:style>
-          <a:lnRef idx="1">
-            <a:schemeClr val="accent1"/>
-          </a:lnRef>
-          <a:fillRef idx="3">
-            <a:schemeClr val="accent1"/>
-          </a:fillRef>
-          <a:effectRef idx="2">
-            <a:schemeClr val="accent1"/>
-          </a:effectRef>
-          <a:fontRef idx="minor">
-            <a:schemeClr val="lt1"/>
-          </a:fontRef>
-        </p:style>
-        <p:txBody>
-          <a:bodyPr rtlCol="0" anchor="ctr"/>
-          <a:lstStyle/>
-          <a:p>
-            <a:pPr algn="ctr"/>
-          </a:p>
-        </p:txBody>
-      </p:sp>
-      <p:sp>
-        <p:nvSpPr>
-          <p:cNvPr id="9" name="TextBox 8"/>
-          <p:cNvSpPr txBox="1"/>
-          <p:nvPr/>
-        </p:nvSpPr>
-        <p:spPr>
-          <a:xfrm>
-            <a:off x="3346704" y="1207007"/>
-            <a:ext cx="2249424" cy="320040"/>
-          </a:xfrm>
-          <a:prstGeom prst="rect">
-            <a:avLst/>
-          </a:prstGeom>
-          <a:noFill/>
-        </p:spPr>
-        <p:txBody>
-          <a:bodyPr wrap="square">
-            <a:spAutoFit/>
-          </a:bodyPr>
-          <a:lstStyle/>
-          <a:p>
-            <a:pPr algn="l"/>
-            <a:r>
-              <a:rPr sz="1600" b="1">
-                <a:solidFill>
-                  <a:srgbClr val="5C6B73"/>
-                </a:solidFill>
-                <a:latin typeface="PingFang SC"/>
-              </a:rPr>
-              <a:t>最强信号</a:t>
-            </a:r>
-          </a:p>
-        </p:txBody>
-      </p:sp>
-      <p:sp>
-        <p:nvSpPr>
-          <p:cNvPr id="10" name="TextBox 9"/>
-          <p:cNvSpPr txBox="1"/>
-          <p:nvPr/>
-        </p:nvSpPr>
-        <p:spPr>
-          <a:xfrm>
-            <a:off x="3346704" y="1554480"/>
-            <a:ext cx="2249424" cy="502920"/>
-          </a:xfrm>
-          <a:prstGeom prst="rect">
-            <a:avLst/>
-          </a:prstGeom>
-          <a:noFill/>
-        </p:spPr>
-        <p:txBody>
-          <a:bodyPr wrap="square">
-            <a:spAutoFit/>
-          </a:bodyPr>
-          <a:lstStyle/>
-          <a:p>
-            <a:pPr algn="l"/>
-            <a:r>
-              <a:rPr sz="2500" b="1">
-                <a:solidFill>
-                  <a:srgbClr val="17324D"/>
-                </a:solidFill>
-                <a:latin typeface="PingFang SC"/>
-              </a:rPr>
-              <a:t>漏电指标仍最难压</a:t>
-            </a:r>
-          </a:p>
-        </p:txBody>
-      </p:sp>
-      <p:sp>
-        <p:nvSpPr>
-          <p:cNvPr id="11" name="TextBox 10"/>
-          <p:cNvSpPr txBox="1"/>
-          <p:nvPr/>
-        </p:nvSpPr>
-        <p:spPr>
-          <a:xfrm>
-            <a:off x="3346704" y="2029967"/>
-            <a:ext cx="2249424" cy="192023"/>
-          </a:xfrm>
-          <a:prstGeom prst="rect">
-            <a:avLst/>
-          </a:prstGeom>
-          <a:noFill/>
-        </p:spPr>
-        <p:txBody>
-          <a:bodyPr wrap="square">
-            <a:spAutoFit/>
-          </a:bodyPr>
-          <a:lstStyle/>
-          <a:p>
-            <a:pPr algn="l"/>
-            <a:r>
-              <a:rPr sz="1100" b="0">
-                <a:solidFill>
-                  <a:srgbClr val="5C6B73"/>
-                </a:solidFill>
-                <a:latin typeface="PingFang SC"/>
-              </a:rPr>
-              <a:t>idoff_a 和 isoff_a 继续占据 top error 列表前列。</a:t>
-            </a:r>
-          </a:p>
-        </p:txBody>
-      </p:sp>
-      <p:sp>
-        <p:nvSpPr>
-          <p:cNvPr id="12" name="Rounded Rectangle 11"/>
-          <p:cNvSpPr/>
-          <p:nvPr/>
-        </p:nvSpPr>
-        <p:spPr>
-          <a:xfrm>
-            <a:off x="5980176" y="1042415"/>
-            <a:ext cx="2834640" cy="1325880"/>
+            <a:off x="3310128" y="1078992"/>
+            <a:ext cx="2286000" cy="1353312"/>
           </a:xfrm>
           <a:prstGeom prst="roundRect">
             <a:avLst/>
@@ -5828,14 +6817,164 @@
       </p:sp>
       <p:sp>
         <p:nvSpPr>
+          <p:cNvPr id="9" name="TextBox 8"/>
+          <p:cNvSpPr txBox="1"/>
+          <p:nvPr/>
+        </p:nvSpPr>
+        <p:spPr>
+          <a:xfrm>
+            <a:off x="3474720" y="1243584"/>
+            <a:ext cx="1956816" cy="320040"/>
+          </a:xfrm>
+          <a:prstGeom prst="rect">
+            <a:avLst/>
+          </a:prstGeom>
+          <a:noFill/>
+        </p:spPr>
+        <p:txBody>
+          <a:bodyPr wrap="square">
+            <a:spAutoFit/>
+          </a:bodyPr>
+          <a:lstStyle/>
+          <a:p>
+            <a:pPr algn="l"/>
+            <a:r>
+              <a:rPr sz="1600" b="1">
+                <a:solidFill>
+                  <a:srgbClr val="5C6B73"/>
+                </a:solidFill>
+                <a:latin typeface="PingFang SC"/>
+              </a:rPr>
+              <a:t>输出闭环</a:t>
+            </a:r>
+          </a:p>
+        </p:txBody>
+      </p:sp>
+      <p:sp>
+        <p:nvSpPr>
+          <p:cNvPr id="10" name="TextBox 9"/>
+          <p:cNvSpPr txBox="1"/>
+          <p:nvPr/>
+        </p:nvSpPr>
+        <p:spPr>
+          <a:xfrm>
+            <a:off x="3474720" y="1591056"/>
+            <a:ext cx="1956816" cy="502920"/>
+          </a:xfrm>
+          <a:prstGeom prst="rect">
+            <a:avLst/>
+          </a:prstGeom>
+          <a:noFill/>
+        </p:spPr>
+        <p:txBody>
+          <a:bodyPr wrap="square">
+            <a:spAutoFit/>
+          </a:bodyPr>
+          <a:lstStyle/>
+          <a:p>
+            <a:pPr algn="l"/>
+            <a:r>
+              <a:rPr sz="2500" b="1">
+                <a:solidFill>
+                  <a:srgbClr val="17324D"/>
+                </a:solidFill>
+                <a:latin typeface="PingFang SC"/>
+              </a:rPr>
+              <a:t>CSV + Markdown + PNG</a:t>
+            </a:r>
+          </a:p>
+        </p:txBody>
+      </p:sp>
+      <p:sp>
+        <p:nvSpPr>
+          <p:cNvPr id="11" name="TextBox 10"/>
+          <p:cNvSpPr txBox="1"/>
+          <p:nvPr/>
+        </p:nvSpPr>
+        <p:spPr>
+          <a:xfrm>
+            <a:off x="3474720" y="2066543"/>
+            <a:ext cx="1956816" cy="219456"/>
+          </a:xfrm>
+          <a:prstGeom prst="rect">
+            <a:avLst/>
+          </a:prstGeom>
+          <a:noFill/>
+        </p:spPr>
+        <p:txBody>
+          <a:bodyPr wrap="square">
+            <a:spAutoFit/>
+          </a:bodyPr>
+          <a:lstStyle/>
+          <a:p>
+            <a:pPr algn="l"/>
+            <a:r>
+              <a:rPr sz="1100" b="0">
+                <a:solidFill>
+                  <a:srgbClr val="5C6B73"/>
+                </a:solidFill>
+                <a:latin typeface="PingFang SC"/>
+              </a:rPr>
+              <a:t>历史上已生成 calibration_output 与 dataset_generation 两类产物。</a:t>
+            </a:r>
+          </a:p>
+        </p:txBody>
+      </p:sp>
+      <p:sp>
+        <p:nvSpPr>
+          <p:cNvPr id="12" name="Rounded Rectangle 11"/>
+          <p:cNvSpPr/>
+          <p:nvPr/>
+        </p:nvSpPr>
+        <p:spPr>
+          <a:xfrm>
+            <a:off x="5797296" y="1078992"/>
+            <a:ext cx="2871216" cy="1353312"/>
+          </a:xfrm>
+          <a:prstGeom prst="roundRect">
+            <a:avLst/>
+          </a:prstGeom>
+          <a:solidFill>
+            <a:srgbClr val="FFFDFC"/>
+          </a:solidFill>
+          <a:ln w="27432">
+            <a:solidFill>
+              <a:srgbClr val="F3B33D"/>
+            </a:solidFill>
+          </a:ln>
+        </p:spPr>
+        <p:style>
+          <a:lnRef idx="1">
+            <a:schemeClr val="accent1"/>
+          </a:lnRef>
+          <a:fillRef idx="3">
+            <a:schemeClr val="accent1"/>
+          </a:fillRef>
+          <a:effectRef idx="2">
+            <a:schemeClr val="accent1"/>
+          </a:effectRef>
+          <a:fontRef idx="minor">
+            <a:schemeClr val="lt1"/>
+          </a:fontRef>
+        </p:style>
+        <p:txBody>
+          <a:bodyPr rtlCol="0" anchor="ctr"/>
+          <a:lstStyle/>
+          <a:p>
+            <a:pPr algn="ctr"/>
+          </a:p>
+        </p:txBody>
+      </p:sp>
+      <p:sp>
+        <p:nvSpPr>
           <p:cNvPr id="13" name="TextBox 12"/>
           <p:cNvSpPr txBox="1"/>
           <p:nvPr/>
         </p:nvSpPr>
         <p:spPr>
           <a:xfrm>
-            <a:off x="6144768" y="1207007"/>
-            <a:ext cx="2505456" cy="320040"/>
+            <a:off x="5961888" y="1243584"/>
+            <a:ext cx="2542032" cy="320040"/>
           </a:xfrm>
           <a:prstGeom prst="rect">
             <a:avLst/>
@@ -5856,7 +6995,7 @@
                 </a:solidFill>
                 <a:latin typeface="PingFang SC"/>
               </a:rPr>
-              <a:t>建模判断</a:t>
+              <a:t>运行入口</a:t>
             </a:r>
           </a:p>
         </p:txBody>
@@ -5869,8 +7008,8 @@
         </p:nvSpPr>
         <p:spPr>
           <a:xfrm>
-            <a:off x="6144768" y="1554480"/>
-            <a:ext cx="2505456" cy="502920"/>
+            <a:off x="5961888" y="1591056"/>
+            <a:ext cx="2542032" cy="502920"/>
           </a:xfrm>
           <a:prstGeom prst="rect">
             <a:avLst/>
@@ -5891,7 +7030,7 @@
                 </a:solidFill>
                 <a:latin typeface="PingFang SC"/>
               </a:rPr>
-              <a:t>先提局部教师解</a:t>
+              <a:t>scripts/run_calibration.py</a:t>
             </a:r>
           </a:p>
         </p:txBody>
@@ -5904,8 +7043,8 @@
         </p:nvSpPr>
         <p:spPr>
           <a:xfrm>
-            <a:off x="6144768" y="2029967"/>
-            <a:ext cx="2505456" cy="192023"/>
+            <a:off x="5961888" y="2066543"/>
+            <a:ext cx="2542032" cy="219456"/>
           </a:xfrm>
           <a:prstGeom prst="rect">
             <a:avLst/>
@@ -5926,21 +7065,80 @@
                 </a:solidFill>
                 <a:latin typeface="PingFang SC"/>
               </a:rPr>
-              <a:t>训练点上全局 refit 未明显拉高误差，优先级仍是局部解质量。</a:t>
-            </a:r>
-          </a:p>
-        </p:txBody>
-      </p:sp>
-      <p:sp>
-        <p:nvSpPr>
-          <p:cNvPr id="16" name="Rounded Rectangle 15"/>
+              <a:t>建议继续使用 scripts/ 下标准入口，而不是兼容 wrapper。</a:t>
+            </a:r>
+          </a:p>
+        </p:txBody>
+      </p:sp>
+      <p:sp>
+        <p:nvSpPr>
+          <p:cNvPr id="16" name="TextBox 15"/>
+          <p:cNvSpPr txBox="1"/>
+          <p:nvPr/>
+        </p:nvSpPr>
+        <p:spPr>
+          <a:xfrm>
+            <a:off x="768096" y="2788920"/>
+            <a:ext cx="5230368" cy="2011680"/>
+          </a:xfrm>
+          <a:prstGeom prst="rect">
+            <a:avLst/>
+          </a:prstGeom>
+          <a:noFill/>
+        </p:spPr>
+        <p:txBody>
+          <a:bodyPr wrap="square">
+            <a:spAutoFit/>
+          </a:bodyPr>
+          <a:lstStyle/>
+          <a:p>
+            <a:pPr algn="l"/>
+            <a:r>
+              <a:rPr sz="1800">
+                <a:solidFill>
+                  <a:srgbClr val="17324D"/>
+                </a:solidFill>
+                <a:latin typeface="PingFang SC"/>
+              </a:rPr>
+              <a:t>当前 `spice` 环境已能跑通全量测试和真实仿真 smoke test。</a:t>
+            </a:r>
+          </a:p>
+          <a:p>
+            <a:pPr algn="l"/>
+            <a:r>
+              <a:rPr sz="1800">
+                <a:solidFill>
+                  <a:srgbClr val="17324D"/>
+                </a:solidFill>
+                <a:latin typeface="PingFang SC"/>
+              </a:rPr>
+              <a:t>新增趋势图与 PPT builder 后，校准结果和汇报材料都能跟随同一套输出目录更新。</a:t>
+            </a:r>
+          </a:p>
+          <a:p>
+            <a:pPr algn="l"/>
+            <a:r>
+              <a:rPr sz="1800">
+                <a:solidFill>
+                  <a:srgbClr val="17324D"/>
+                </a:solidFill>
+                <a:latin typeface="PingFang SC"/>
+              </a:rPr>
+              <a:t>本轮新增产物重点补上了参数随 W/L 变化的趋势视图，方便检查曲面形状是否符合预期。</a:t>
+            </a:r>
+          </a:p>
+        </p:txBody>
+      </p:sp>
+      <p:sp>
+        <p:nvSpPr>
+          <p:cNvPr id="17" name="Rounded Rectangle 16"/>
           <p:cNvSpPr/>
           <p:nvPr/>
         </p:nvSpPr>
         <p:spPr>
           <a:xfrm>
-            <a:off x="749808" y="2743200"/>
-            <a:ext cx="5559552" cy="3035808"/>
+            <a:off x="6309360" y="1920240"/>
+            <a:ext cx="5212080" cy="4434840"/>
           </a:xfrm>
           <a:prstGeom prst="roundRect">
             <a:avLst/>
@@ -5978,14 +7176,14 @@
       </p:sp>
       <p:sp>
         <p:nvSpPr>
-          <p:cNvPr id="17" name="TextBox 16"/>
-          <p:cNvSpPr txBox="1"/>
-          <p:nvPr/>
-        </p:nvSpPr>
-        <p:spPr>
-          <a:xfrm>
-            <a:off x="914400" y="2852928"/>
-            <a:ext cx="5230368" cy="274320"/>
+          <p:cNvPr id="18" name="TextBox 17"/>
+          <p:cNvSpPr txBox="1"/>
+          <p:nvPr/>
+        </p:nvSpPr>
+        <p:spPr>
+          <a:xfrm>
+            <a:off x="6473952" y="2011680"/>
+            <a:ext cx="4882896" cy="274320"/>
           </a:xfrm>
           <a:prstGeom prst="rect">
             <a:avLst/>
@@ -6006,304 +7204,14 @@
                 </a:solidFill>
                 <a:latin typeface="PingFang SC"/>
               </a:rPr>
-              <a:t>各指标 worst-case</a:t>
-            </a:r>
-          </a:p>
-        </p:txBody>
-      </p:sp>
-      <p:sp>
-        <p:nvSpPr>
-          <p:cNvPr id="18" name="TextBox 17"/>
-          <p:cNvSpPr txBox="1"/>
-          <p:nvPr/>
-        </p:nvSpPr>
-        <p:spPr>
-          <a:xfrm>
-            <a:off x="950976" y="3255264"/>
-            <a:ext cx="5157216" cy="329184"/>
-          </a:xfrm>
-          <a:prstGeom prst="rect">
-            <a:avLst/>
-          </a:prstGeom>
-          <a:noFill/>
-        </p:spPr>
-        <p:txBody>
-          <a:bodyPr wrap="square">
-            <a:spAutoFit/>
-          </a:bodyPr>
-          <a:lstStyle/>
-          <a:p>
-            <a:pPr algn="l"/>
-            <a:r>
-              <a:rPr sz="1300" b="0">
-                <a:solidFill>
-                  <a:srgbClr val="17324D"/>
-                </a:solidFill>
-                <a:latin typeface="Menlo"/>
-              </a:rPr>
-              <a:t>idoff_a     5.10%  @ W=0.56, L=1.5</a:t>
-            </a:r>
-          </a:p>
-        </p:txBody>
-      </p:sp>
-      <p:sp>
-        <p:nvSpPr>
-          <p:cNvPr id="19" name="TextBox 18"/>
-          <p:cNvSpPr txBox="1"/>
-          <p:nvPr/>
-        </p:nvSpPr>
-        <p:spPr>
-          <a:xfrm>
-            <a:off x="950976" y="3639312"/>
-            <a:ext cx="5157216" cy="329184"/>
-          </a:xfrm>
-          <a:prstGeom prst="rect">
-            <a:avLst/>
-          </a:prstGeom>
-          <a:noFill/>
-        </p:spPr>
-        <p:txBody>
-          <a:bodyPr wrap="square">
-            <a:spAutoFit/>
-          </a:bodyPr>
-          <a:lstStyle/>
-          <a:p>
-            <a:pPr algn="l"/>
-            <a:r>
-              <a:rPr sz="1300" b="0">
-                <a:solidFill>
-                  <a:srgbClr val="17324D"/>
-                </a:solidFill>
-                <a:latin typeface="Menlo"/>
-              </a:rPr>
-              <a:t>isoff_a     4.89%  @ W=0.56, L=1.5</a:t>
-            </a:r>
-          </a:p>
-        </p:txBody>
-      </p:sp>
-      <p:sp>
-        <p:nvSpPr>
-          <p:cNvPr id="20" name="TextBox 19"/>
-          <p:cNvSpPr txBox="1"/>
-          <p:nvPr/>
-        </p:nvSpPr>
-        <p:spPr>
-          <a:xfrm>
-            <a:off x="950976" y="4023360"/>
-            <a:ext cx="5157216" cy="329184"/>
-          </a:xfrm>
-          <a:prstGeom prst="rect">
-            <a:avLst/>
-          </a:prstGeom>
-          <a:noFill/>
-        </p:spPr>
-        <p:txBody>
-          <a:bodyPr wrap="square">
-            <a:spAutoFit/>
-          </a:bodyPr>
-          <a:lstStyle/>
-          <a:p>
-            <a:pPr algn="l"/>
-            <a:r>
-              <a:rPr sz="1300" b="0">
-                <a:solidFill>
-                  <a:srgbClr val="17324D"/>
-                </a:solidFill>
-                <a:latin typeface="Menlo"/>
-              </a:rPr>
-              <a:t>vtlin_v     4.30%  @ W=2.7, L=0.28</a:t>
-            </a:r>
-          </a:p>
-        </p:txBody>
-      </p:sp>
-      <p:sp>
-        <p:nvSpPr>
-          <p:cNvPr id="21" name="TextBox 20"/>
-          <p:cNvSpPr txBox="1"/>
-          <p:nvPr/>
-        </p:nvSpPr>
-        <p:spPr>
-          <a:xfrm>
-            <a:off x="950976" y="4407408"/>
-            <a:ext cx="5157216" cy="329184"/>
-          </a:xfrm>
-          <a:prstGeom prst="rect">
-            <a:avLst/>
-          </a:prstGeom>
-          <a:noFill/>
-        </p:spPr>
-        <p:txBody>
-          <a:bodyPr wrap="square">
-            <a:spAutoFit/>
-          </a:bodyPr>
-          <a:lstStyle/>
-          <a:p>
-            <a:pPr algn="l"/>
-            <a:r>
-              <a:rPr sz="1300" b="0">
-                <a:solidFill>
-                  <a:srgbClr val="17324D"/>
-                </a:solidFill>
-                <a:latin typeface="Menlo"/>
-              </a:rPr>
-              <a:t>vtsat_v     4.28%  @ W=0.28, L=0.56</a:t>
-            </a:r>
-          </a:p>
-        </p:txBody>
-      </p:sp>
-      <p:sp>
-        <p:nvSpPr>
-          <p:cNvPr id="22" name="TextBox 21"/>
-          <p:cNvSpPr txBox="1"/>
-          <p:nvPr/>
-        </p:nvSpPr>
-        <p:spPr>
-          <a:xfrm>
-            <a:off x="950976" y="4791456"/>
-            <a:ext cx="5157216" cy="329184"/>
-          </a:xfrm>
-          <a:prstGeom prst="rect">
-            <a:avLst/>
-          </a:prstGeom>
-          <a:noFill/>
-        </p:spPr>
-        <p:txBody>
-          <a:bodyPr wrap="square">
-            <a:spAutoFit/>
-          </a:bodyPr>
-          <a:lstStyle/>
-          <a:p>
-            <a:pPr algn="l"/>
-            <a:r>
-              <a:rPr sz="1300" b="0">
-                <a:solidFill>
-                  <a:srgbClr val="17324D"/>
-                </a:solidFill>
-                <a:latin typeface="Menlo"/>
-              </a:rPr>
-              <a:t>idlin_a     4.04%  @ W=1.5, L=0.056</a:t>
-            </a:r>
-          </a:p>
-        </p:txBody>
-      </p:sp>
-      <p:sp>
-        <p:nvSpPr>
-          <p:cNvPr id="23" name="TextBox 22"/>
-          <p:cNvSpPr txBox="1"/>
-          <p:nvPr/>
-        </p:nvSpPr>
-        <p:spPr>
-          <a:xfrm>
-            <a:off x="950976" y="5175504"/>
-            <a:ext cx="5157216" cy="329184"/>
-          </a:xfrm>
-          <a:prstGeom prst="rect">
-            <a:avLst/>
-          </a:prstGeom>
-          <a:noFill/>
-        </p:spPr>
-        <p:txBody>
-          <a:bodyPr wrap="square">
-            <a:spAutoFit/>
-          </a:bodyPr>
-          <a:lstStyle/>
-          <a:p>
-            <a:pPr algn="l"/>
-            <a:r>
-              <a:rPr sz="1300" b="0">
-                <a:solidFill>
-                  <a:srgbClr val="17324D"/>
-                </a:solidFill>
-                <a:latin typeface="Menlo"/>
-              </a:rPr>
-              <a:t>idsat_a     3.85%  @ W=1.5, L=0.056</a:t>
-            </a:r>
-          </a:p>
-        </p:txBody>
-      </p:sp>
-      <p:sp>
-        <p:nvSpPr>
-          <p:cNvPr id="24" name="Rounded Rectangle 23"/>
-          <p:cNvSpPr/>
-          <p:nvPr/>
-        </p:nvSpPr>
-        <p:spPr>
-          <a:xfrm>
-            <a:off x="6528816" y="1993392"/>
-            <a:ext cx="4992624" cy="4224528"/>
-          </a:xfrm>
-          <a:prstGeom prst="roundRect">
-            <a:avLst/>
-          </a:prstGeom>
-          <a:solidFill>
-            <a:srgbClr val="FFFDFC"/>
-          </a:solidFill>
-          <a:ln>
-            <a:solidFill>
-              <a:srgbClr val="D9CDB8"/>
-            </a:solidFill>
-          </a:ln>
-        </p:spPr>
-        <p:style>
-          <a:lnRef idx="1">
-            <a:schemeClr val="accent1"/>
-          </a:lnRef>
-          <a:fillRef idx="3">
-            <a:schemeClr val="accent1"/>
-          </a:fillRef>
-          <a:effectRef idx="2">
-            <a:schemeClr val="accent1"/>
-          </a:effectRef>
-          <a:fontRef idx="minor">
-            <a:schemeClr val="lt1"/>
-          </a:fontRef>
-        </p:style>
-        <p:txBody>
-          <a:bodyPr rtlCol="0" anchor="ctr"/>
-          <a:lstStyle/>
-          <a:p>
-            <a:pPr algn="ctr"/>
-          </a:p>
-        </p:txBody>
-      </p:sp>
-      <p:sp>
-        <p:nvSpPr>
-          <p:cNvPr id="25" name="TextBox 24"/>
-          <p:cNvSpPr txBox="1"/>
-          <p:nvPr/>
-        </p:nvSpPr>
-        <p:spPr>
-          <a:xfrm>
-            <a:off x="6693407" y="2084832"/>
-            <a:ext cx="4663440" cy="274320"/>
-          </a:xfrm>
-          <a:prstGeom prst="rect">
-            <a:avLst/>
-          </a:prstGeom>
-          <a:noFill/>
-        </p:spPr>
-        <p:txBody>
-          <a:bodyPr wrap="square">
-            <a:spAutoFit/>
-          </a:bodyPr>
-          <a:lstStyle/>
-          <a:p>
-            <a:pPr algn="l"/>
-            <a:r>
-              <a:rPr sz="1600" b="1">
-                <a:solidFill>
-                  <a:srgbClr val="17324D"/>
-                </a:solidFill>
-                <a:latin typeface="PingFang SC"/>
-              </a:rPr>
-              <a:t>idoff target vs simulated</a:t>
+              <a:t>参数随 L 变化</a:t>
             </a:r>
           </a:p>
         </p:txBody>
       </p:sp>
       <p:pic>
         <p:nvPicPr>
-          <p:cNvPr id="26" name="Picture 25" descr="target_vs_simulated_idoff_a.png"/>
+          <p:cNvPr id="19" name="Picture 18" descr="parameter_trends_vs_l.png"/>
           <p:cNvPicPr>
             <a:picLocks noChangeAspect="1"/>
           </p:cNvPicPr>
@@ -6317,8 +7225,8 @@
         </p:blipFill>
         <p:spPr>
           <a:xfrm>
-            <a:off x="6665976" y="2432304"/>
-            <a:ext cx="4718304" cy="3648456"/>
+            <a:off x="6446520" y="2359152"/>
+            <a:ext cx="4937760" cy="3858768"/>
           </a:xfrm>
           <a:prstGeom prst="rect">
             <a:avLst/>
@@ -6395,7 +7303,7 @@
         <p:spPr>
           <a:xfrm>
             <a:off x="658368" y="402336"/>
-            <a:ext cx="2926080" cy="438912"/>
+            <a:ext cx="3200400" cy="438912"/>
           </a:xfrm>
           <a:prstGeom prst="rect">
             <a:avLst/>
@@ -6416,7 +7324,7 @@
                 </a:solidFill>
                 <a:latin typeface="PingFang SC"/>
               </a:rPr>
-              <a:t>5. 误差热点</a:t>
+              <a:t>5. 当前结果总览</a:t>
             </a:r>
           </a:p>
         </p:txBody>
@@ -6429,8 +7337,458 @@
         </p:nvSpPr>
         <p:spPr>
           <a:xfrm>
-            <a:off x="749808" y="1078992"/>
-            <a:ext cx="5248656" cy="2697480"/>
+            <a:off x="749808" y="1042415"/>
+            <a:ext cx="2212848" cy="1325880"/>
+          </a:xfrm>
+          <a:prstGeom prst="roundRect">
+            <a:avLst/>
+          </a:prstGeom>
+          <a:solidFill>
+            <a:srgbClr val="FFFDFC"/>
+          </a:solidFill>
+          <a:ln w="27432">
+            <a:solidFill>
+              <a:srgbClr val="AA5B10"/>
+            </a:solidFill>
+          </a:ln>
+        </p:spPr>
+        <p:style>
+          <a:lnRef idx="1">
+            <a:schemeClr val="accent1"/>
+          </a:lnRef>
+          <a:fillRef idx="3">
+            <a:schemeClr val="accent1"/>
+          </a:fillRef>
+          <a:effectRef idx="2">
+            <a:schemeClr val="accent1"/>
+          </a:effectRef>
+          <a:fontRef idx="minor">
+            <a:schemeClr val="lt1"/>
+          </a:fontRef>
+        </p:style>
+        <p:txBody>
+          <a:bodyPr rtlCol="0" anchor="ctr"/>
+          <a:lstStyle/>
+          <a:p>
+            <a:pPr algn="ctr"/>
+          </a:p>
+        </p:txBody>
+      </p:sp>
+      <p:sp>
+        <p:nvSpPr>
+          <p:cNvPr id="5" name="TextBox 4"/>
+          <p:cNvSpPr txBox="1"/>
+          <p:nvPr/>
+        </p:nvSpPr>
+        <p:spPr>
+          <a:xfrm>
+            <a:off x="914400" y="1207007"/>
+            <a:ext cx="1883664" cy="320040"/>
+          </a:xfrm>
+          <a:prstGeom prst="rect">
+            <a:avLst/>
+          </a:prstGeom>
+          <a:noFill/>
+        </p:spPr>
+        <p:txBody>
+          <a:bodyPr wrap="square">
+            <a:spAutoFit/>
+          </a:bodyPr>
+          <a:lstStyle/>
+          <a:p>
+            <a:pPr algn="l"/>
+            <a:r>
+              <a:rPr sz="1600" b="1">
+                <a:solidFill>
+                  <a:srgbClr val="5C6B73"/>
+                </a:solidFill>
+                <a:latin typeface="PingFang SC"/>
+              </a:rPr>
+              <a:t>worst-case</a:t>
+            </a:r>
+          </a:p>
+        </p:txBody>
+      </p:sp>
+      <p:sp>
+        <p:nvSpPr>
+          <p:cNvPr id="6" name="TextBox 5"/>
+          <p:cNvSpPr txBox="1"/>
+          <p:nvPr/>
+        </p:nvSpPr>
+        <p:spPr>
+          <a:xfrm>
+            <a:off x="914400" y="1554480"/>
+            <a:ext cx="1883664" cy="502920"/>
+          </a:xfrm>
+          <a:prstGeom prst="rect">
+            <a:avLst/>
+          </a:prstGeom>
+          <a:noFill/>
+        </p:spPr>
+        <p:txBody>
+          <a:bodyPr wrap="square">
+            <a:spAutoFit/>
+          </a:bodyPr>
+          <a:lstStyle/>
+          <a:p>
+            <a:pPr algn="l"/>
+            <a:r>
+              <a:rPr sz="2500" b="1">
+                <a:solidFill>
+                  <a:srgbClr val="17324D"/>
+                </a:solidFill>
+                <a:latin typeface="PingFang SC"/>
+              </a:rPr>
+              <a:t>5.10%</a:t>
+            </a:r>
+          </a:p>
+        </p:txBody>
+      </p:sp>
+      <p:sp>
+        <p:nvSpPr>
+          <p:cNvPr id="7" name="TextBox 6"/>
+          <p:cNvSpPr txBox="1"/>
+          <p:nvPr/>
+        </p:nvSpPr>
+        <p:spPr>
+          <a:xfrm>
+            <a:off x="914400" y="2029967"/>
+            <a:ext cx="1883664" cy="192023"/>
+          </a:xfrm>
+          <a:prstGeom prst="rect">
+            <a:avLst/>
+          </a:prstGeom>
+          <a:noFill/>
+        </p:spPr>
+        <p:txBody>
+          <a:bodyPr wrap="square">
+            <a:spAutoFit/>
+          </a:bodyPr>
+          <a:lstStyle/>
+          <a:p>
+            <a:pPr algn="l"/>
+            <a:r>
+              <a:rPr sz="1100" b="0">
+                <a:solidFill>
+                  <a:srgbClr val="5C6B73"/>
+                </a:solidFill>
+                <a:latin typeface="PingFang SC"/>
+              </a:rPr>
+              <a:t>当前默认结果仍高于 3% 验收目标。</a:t>
+            </a:r>
+          </a:p>
+        </p:txBody>
+      </p:sp>
+      <p:sp>
+        <p:nvSpPr>
+          <p:cNvPr id="8" name="Rounded Rectangle 7"/>
+          <p:cNvSpPr/>
+          <p:nvPr/>
+        </p:nvSpPr>
+        <p:spPr>
+          <a:xfrm>
+            <a:off x="3182112" y="1042415"/>
+            <a:ext cx="2578608" cy="1325880"/>
+          </a:xfrm>
+          <a:prstGeom prst="roundRect">
+            <a:avLst/>
+          </a:prstGeom>
+          <a:solidFill>
+            <a:srgbClr val="FFFDFC"/>
+          </a:solidFill>
+          <a:ln w="27432">
+            <a:solidFill>
+              <a:srgbClr val="E07A5F"/>
+            </a:solidFill>
+          </a:ln>
+        </p:spPr>
+        <p:style>
+          <a:lnRef idx="1">
+            <a:schemeClr val="accent1"/>
+          </a:lnRef>
+          <a:fillRef idx="3">
+            <a:schemeClr val="accent1"/>
+          </a:fillRef>
+          <a:effectRef idx="2">
+            <a:schemeClr val="accent1"/>
+          </a:effectRef>
+          <a:fontRef idx="minor">
+            <a:schemeClr val="lt1"/>
+          </a:fontRef>
+        </p:style>
+        <p:txBody>
+          <a:bodyPr rtlCol="0" anchor="ctr"/>
+          <a:lstStyle/>
+          <a:p>
+            <a:pPr algn="ctr"/>
+          </a:p>
+        </p:txBody>
+      </p:sp>
+      <p:sp>
+        <p:nvSpPr>
+          <p:cNvPr id="9" name="TextBox 8"/>
+          <p:cNvSpPr txBox="1"/>
+          <p:nvPr/>
+        </p:nvSpPr>
+        <p:spPr>
+          <a:xfrm>
+            <a:off x="3346704" y="1207007"/>
+            <a:ext cx="2249424" cy="320040"/>
+          </a:xfrm>
+          <a:prstGeom prst="rect">
+            <a:avLst/>
+          </a:prstGeom>
+          <a:noFill/>
+        </p:spPr>
+        <p:txBody>
+          <a:bodyPr wrap="square">
+            <a:spAutoFit/>
+          </a:bodyPr>
+          <a:lstStyle/>
+          <a:p>
+            <a:pPr algn="l"/>
+            <a:r>
+              <a:rPr sz="1600" b="1">
+                <a:solidFill>
+                  <a:srgbClr val="5C6B73"/>
+                </a:solidFill>
+                <a:latin typeface="PingFang SC"/>
+              </a:rPr>
+              <a:t>最强信号</a:t>
+            </a:r>
+          </a:p>
+        </p:txBody>
+      </p:sp>
+      <p:sp>
+        <p:nvSpPr>
+          <p:cNvPr id="10" name="TextBox 9"/>
+          <p:cNvSpPr txBox="1"/>
+          <p:nvPr/>
+        </p:nvSpPr>
+        <p:spPr>
+          <a:xfrm>
+            <a:off x="3346704" y="1554480"/>
+            <a:ext cx="2249424" cy="502920"/>
+          </a:xfrm>
+          <a:prstGeom prst="rect">
+            <a:avLst/>
+          </a:prstGeom>
+          <a:noFill/>
+        </p:spPr>
+        <p:txBody>
+          <a:bodyPr wrap="square">
+            <a:spAutoFit/>
+          </a:bodyPr>
+          <a:lstStyle/>
+          <a:p>
+            <a:pPr algn="l"/>
+            <a:r>
+              <a:rPr sz="2500" b="1">
+                <a:solidFill>
+                  <a:srgbClr val="17324D"/>
+                </a:solidFill>
+                <a:latin typeface="PingFang SC"/>
+              </a:rPr>
+              <a:t>漏电指标仍最难压</a:t>
+            </a:r>
+          </a:p>
+        </p:txBody>
+      </p:sp>
+      <p:sp>
+        <p:nvSpPr>
+          <p:cNvPr id="11" name="TextBox 10"/>
+          <p:cNvSpPr txBox="1"/>
+          <p:nvPr/>
+        </p:nvSpPr>
+        <p:spPr>
+          <a:xfrm>
+            <a:off x="3346704" y="2029967"/>
+            <a:ext cx="2249424" cy="192023"/>
+          </a:xfrm>
+          <a:prstGeom prst="rect">
+            <a:avLst/>
+          </a:prstGeom>
+          <a:noFill/>
+        </p:spPr>
+        <p:txBody>
+          <a:bodyPr wrap="square">
+            <a:spAutoFit/>
+          </a:bodyPr>
+          <a:lstStyle/>
+          <a:p>
+            <a:pPr algn="l"/>
+            <a:r>
+              <a:rPr sz="1100" b="0">
+                <a:solidFill>
+                  <a:srgbClr val="5C6B73"/>
+                </a:solidFill>
+                <a:latin typeface="PingFang SC"/>
+              </a:rPr>
+              <a:t>idoff_a 和 isoff_a 继续占据 top error 列表前列。</a:t>
+            </a:r>
+          </a:p>
+        </p:txBody>
+      </p:sp>
+      <p:sp>
+        <p:nvSpPr>
+          <p:cNvPr id="12" name="Rounded Rectangle 11"/>
+          <p:cNvSpPr/>
+          <p:nvPr/>
+        </p:nvSpPr>
+        <p:spPr>
+          <a:xfrm>
+            <a:off x="5980176" y="1042415"/>
+            <a:ext cx="2834640" cy="1325880"/>
+          </a:xfrm>
+          <a:prstGeom prst="roundRect">
+            <a:avLst/>
+          </a:prstGeom>
+          <a:solidFill>
+            <a:srgbClr val="FFFDFC"/>
+          </a:solidFill>
+          <a:ln w="27432">
+            <a:solidFill>
+              <a:srgbClr val="7AC6D2"/>
+            </a:solidFill>
+          </a:ln>
+        </p:spPr>
+        <p:style>
+          <a:lnRef idx="1">
+            <a:schemeClr val="accent1"/>
+          </a:lnRef>
+          <a:fillRef idx="3">
+            <a:schemeClr val="accent1"/>
+          </a:fillRef>
+          <a:effectRef idx="2">
+            <a:schemeClr val="accent1"/>
+          </a:effectRef>
+          <a:fontRef idx="minor">
+            <a:schemeClr val="lt1"/>
+          </a:fontRef>
+        </p:style>
+        <p:txBody>
+          <a:bodyPr rtlCol="0" anchor="ctr"/>
+          <a:lstStyle/>
+          <a:p>
+            <a:pPr algn="ctr"/>
+          </a:p>
+        </p:txBody>
+      </p:sp>
+      <p:sp>
+        <p:nvSpPr>
+          <p:cNvPr id="13" name="TextBox 12"/>
+          <p:cNvSpPr txBox="1"/>
+          <p:nvPr/>
+        </p:nvSpPr>
+        <p:spPr>
+          <a:xfrm>
+            <a:off x="6144768" y="1207007"/>
+            <a:ext cx="2505456" cy="320040"/>
+          </a:xfrm>
+          <a:prstGeom prst="rect">
+            <a:avLst/>
+          </a:prstGeom>
+          <a:noFill/>
+        </p:spPr>
+        <p:txBody>
+          <a:bodyPr wrap="square">
+            <a:spAutoFit/>
+          </a:bodyPr>
+          <a:lstStyle/>
+          <a:p>
+            <a:pPr algn="l"/>
+            <a:r>
+              <a:rPr sz="1600" b="1">
+                <a:solidFill>
+                  <a:srgbClr val="5C6B73"/>
+                </a:solidFill>
+                <a:latin typeface="PingFang SC"/>
+              </a:rPr>
+              <a:t>建模判断</a:t>
+            </a:r>
+          </a:p>
+        </p:txBody>
+      </p:sp>
+      <p:sp>
+        <p:nvSpPr>
+          <p:cNvPr id="14" name="TextBox 13"/>
+          <p:cNvSpPr txBox="1"/>
+          <p:nvPr/>
+        </p:nvSpPr>
+        <p:spPr>
+          <a:xfrm>
+            <a:off x="6144768" y="1554480"/>
+            <a:ext cx="2505456" cy="502920"/>
+          </a:xfrm>
+          <a:prstGeom prst="rect">
+            <a:avLst/>
+          </a:prstGeom>
+          <a:noFill/>
+        </p:spPr>
+        <p:txBody>
+          <a:bodyPr wrap="square">
+            <a:spAutoFit/>
+          </a:bodyPr>
+          <a:lstStyle/>
+          <a:p>
+            <a:pPr algn="l"/>
+            <a:r>
+              <a:rPr sz="2500" b="1">
+                <a:solidFill>
+                  <a:srgbClr val="17324D"/>
+                </a:solidFill>
+                <a:latin typeface="PingFang SC"/>
+              </a:rPr>
+              <a:t>先提局部教师解</a:t>
+            </a:r>
+          </a:p>
+        </p:txBody>
+      </p:sp>
+      <p:sp>
+        <p:nvSpPr>
+          <p:cNvPr id="15" name="TextBox 14"/>
+          <p:cNvSpPr txBox="1"/>
+          <p:nvPr/>
+        </p:nvSpPr>
+        <p:spPr>
+          <a:xfrm>
+            <a:off x="6144768" y="2029967"/>
+            <a:ext cx="2505456" cy="192023"/>
+          </a:xfrm>
+          <a:prstGeom prst="rect">
+            <a:avLst/>
+          </a:prstGeom>
+          <a:noFill/>
+        </p:spPr>
+        <p:txBody>
+          <a:bodyPr wrap="square">
+            <a:spAutoFit/>
+          </a:bodyPr>
+          <a:lstStyle/>
+          <a:p>
+            <a:pPr algn="l"/>
+            <a:r>
+              <a:rPr sz="1100" b="0">
+                <a:solidFill>
+                  <a:srgbClr val="5C6B73"/>
+                </a:solidFill>
+                <a:latin typeface="PingFang SC"/>
+              </a:rPr>
+              <a:t>训练点上全局 refit 未明显拉高误差，优先级仍是局部解质量。</a:t>
+            </a:r>
+          </a:p>
+        </p:txBody>
+      </p:sp>
+      <p:sp>
+        <p:nvSpPr>
+          <p:cNvPr id="16" name="Rounded Rectangle 15"/>
+          <p:cNvSpPr/>
+          <p:nvPr/>
+        </p:nvSpPr>
+        <p:spPr>
+          <a:xfrm>
+            <a:off x="749808" y="2743200"/>
+            <a:ext cx="5559552" cy="3035808"/>
           </a:xfrm>
           <a:prstGeom prst="roundRect">
             <a:avLst/>
@@ -6468,14 +7826,14 @@
       </p:sp>
       <p:sp>
         <p:nvSpPr>
-          <p:cNvPr id="5" name="TextBox 4"/>
-          <p:cNvSpPr txBox="1"/>
-          <p:nvPr/>
-        </p:nvSpPr>
-        <p:spPr>
-          <a:xfrm>
-            <a:off x="914400" y="1188719"/>
-            <a:ext cx="4919472" cy="274320"/>
+          <p:cNvPr id="17" name="TextBox 16"/>
+          <p:cNvSpPr txBox="1"/>
+          <p:nvPr/>
+        </p:nvSpPr>
+        <p:spPr>
+          <a:xfrm>
+            <a:off x="914400" y="2852928"/>
+            <a:ext cx="5230368" cy="274320"/>
           </a:xfrm>
           <a:prstGeom prst="rect">
             <a:avLst/>
@@ -6496,21 +7854,21 @@
                 </a:solidFill>
                 <a:latin typeface="PingFang SC"/>
               </a:rPr>
-              <a:t>Top error points</a:t>
-            </a:r>
-          </a:p>
-        </p:txBody>
-      </p:sp>
-      <p:sp>
-        <p:nvSpPr>
-          <p:cNvPr id="6" name="TextBox 5"/>
-          <p:cNvSpPr txBox="1"/>
-          <p:nvPr/>
-        </p:nvSpPr>
-        <p:spPr>
-          <a:xfrm>
-            <a:off x="950976" y="1591056"/>
-            <a:ext cx="4846320" cy="329184"/>
+              <a:t>各指标 worst-case</a:t>
+            </a:r>
+          </a:p>
+        </p:txBody>
+      </p:sp>
+      <p:sp>
+        <p:nvSpPr>
+          <p:cNvPr id="18" name="TextBox 17"/>
+          <p:cNvSpPr txBox="1"/>
+          <p:nvPr/>
+        </p:nvSpPr>
+        <p:spPr>
+          <a:xfrm>
+            <a:off x="950976" y="3255264"/>
+            <a:ext cx="5157216" cy="329184"/>
           </a:xfrm>
           <a:prstGeom prst="rect">
             <a:avLst/>
@@ -6531,21 +7889,21 @@
                 </a:solidFill>
                 <a:latin typeface="Menlo"/>
               </a:rPr>
-              <a:t>1. idoff_a  5.10%  @ (0.56, 1.5)</a:t>
-            </a:r>
-          </a:p>
-        </p:txBody>
-      </p:sp>
-      <p:sp>
-        <p:nvSpPr>
-          <p:cNvPr id="7" name="TextBox 6"/>
-          <p:cNvSpPr txBox="1"/>
-          <p:nvPr/>
-        </p:nvSpPr>
-        <p:spPr>
-          <a:xfrm>
-            <a:off x="950976" y="1975104"/>
-            <a:ext cx="4846320" cy="329184"/>
+              <a:t>idoff_a     5.10%  @ W=0.56, L=1.5</a:t>
+            </a:r>
+          </a:p>
+        </p:txBody>
+      </p:sp>
+      <p:sp>
+        <p:nvSpPr>
+          <p:cNvPr id="19" name="TextBox 18"/>
+          <p:cNvSpPr txBox="1"/>
+          <p:nvPr/>
+        </p:nvSpPr>
+        <p:spPr>
+          <a:xfrm>
+            <a:off x="950976" y="3639312"/>
+            <a:ext cx="5157216" cy="329184"/>
           </a:xfrm>
           <a:prstGeom prst="rect">
             <a:avLst/>
@@ -6566,21 +7924,21 @@
                 </a:solidFill>
                 <a:latin typeface="Menlo"/>
               </a:rPr>
-              <a:t>2. idoff_a  5.10%  @ (0.14, 0.028)</a:t>
-            </a:r>
-          </a:p>
-        </p:txBody>
-      </p:sp>
-      <p:sp>
-        <p:nvSpPr>
-          <p:cNvPr id="8" name="TextBox 7"/>
-          <p:cNvSpPr txBox="1"/>
-          <p:nvPr/>
-        </p:nvSpPr>
-        <p:spPr>
-          <a:xfrm>
-            <a:off x="950976" y="2359152"/>
-            <a:ext cx="4846320" cy="329184"/>
+              <a:t>isoff_a     4.89%  @ W=0.56, L=1.5</a:t>
+            </a:r>
+          </a:p>
+        </p:txBody>
+      </p:sp>
+      <p:sp>
+        <p:nvSpPr>
+          <p:cNvPr id="20" name="TextBox 19"/>
+          <p:cNvSpPr txBox="1"/>
+          <p:nvPr/>
+        </p:nvSpPr>
+        <p:spPr>
+          <a:xfrm>
+            <a:off x="950976" y="4023360"/>
+            <a:ext cx="5157216" cy="329184"/>
           </a:xfrm>
           <a:prstGeom prst="rect">
             <a:avLst/>
@@ -6601,21 +7959,21 @@
                 </a:solidFill>
                 <a:latin typeface="Menlo"/>
               </a:rPr>
-              <a:t>3. isoff_a  4.89%  @ (0.56, 1.5)</a:t>
-            </a:r>
-          </a:p>
-        </p:txBody>
-      </p:sp>
-      <p:sp>
-        <p:nvSpPr>
-          <p:cNvPr id="9" name="TextBox 8"/>
-          <p:cNvSpPr txBox="1"/>
-          <p:nvPr/>
-        </p:nvSpPr>
-        <p:spPr>
-          <a:xfrm>
-            <a:off x="950976" y="2743200"/>
-            <a:ext cx="4846320" cy="329184"/>
+              <a:t>vtlin_v     4.30%  @ W=2.7, L=0.28</a:t>
+            </a:r>
+          </a:p>
+        </p:txBody>
+      </p:sp>
+      <p:sp>
+        <p:nvSpPr>
+          <p:cNvPr id="21" name="TextBox 20"/>
+          <p:cNvSpPr txBox="1"/>
+          <p:nvPr/>
+        </p:nvSpPr>
+        <p:spPr>
+          <a:xfrm>
+            <a:off x="950976" y="4407408"/>
+            <a:ext cx="5157216" cy="329184"/>
           </a:xfrm>
           <a:prstGeom prst="rect">
             <a:avLst/>
@@ -6636,21 +7994,21 @@
                 </a:solidFill>
                 <a:latin typeface="Menlo"/>
               </a:rPr>
-              <a:t>4. isoff_a  4.39%  @ (2.7, 0.28)</a:t>
-            </a:r>
-          </a:p>
-        </p:txBody>
-      </p:sp>
-      <p:sp>
-        <p:nvSpPr>
-          <p:cNvPr id="10" name="TextBox 9"/>
-          <p:cNvSpPr txBox="1"/>
-          <p:nvPr/>
-        </p:nvSpPr>
-        <p:spPr>
-          <a:xfrm>
-            <a:off x="950976" y="3127248"/>
-            <a:ext cx="4846320" cy="329184"/>
+              <a:t>vtsat_v     4.28%  @ W=0.28, L=0.56</a:t>
+            </a:r>
+          </a:p>
+        </p:txBody>
+      </p:sp>
+      <p:sp>
+        <p:nvSpPr>
+          <p:cNvPr id="22" name="TextBox 21"/>
+          <p:cNvSpPr txBox="1"/>
+          <p:nvPr/>
+        </p:nvSpPr>
+        <p:spPr>
+          <a:xfrm>
+            <a:off x="950976" y="4791456"/>
+            <a:ext cx="5157216" cy="329184"/>
           </a:xfrm>
           <a:prstGeom prst="rect">
             <a:avLst/>
@@ -6671,21 +8029,21 @@
                 </a:solidFill>
                 <a:latin typeface="Menlo"/>
               </a:rPr>
-              <a:t>5. idoff_a  4.36%  @ (0.28, 0.56)</a:t>
-            </a:r>
-          </a:p>
-        </p:txBody>
-      </p:sp>
-      <p:sp>
-        <p:nvSpPr>
-          <p:cNvPr id="11" name="TextBox 10"/>
-          <p:cNvSpPr txBox="1"/>
-          <p:nvPr/>
-        </p:nvSpPr>
-        <p:spPr>
-          <a:xfrm>
-            <a:off x="950976" y="3511296"/>
-            <a:ext cx="4846320" cy="329184"/>
+              <a:t>idlin_a     4.04%  @ W=1.5, L=0.056</a:t>
+            </a:r>
+          </a:p>
+        </p:txBody>
+      </p:sp>
+      <p:sp>
+        <p:nvSpPr>
+          <p:cNvPr id="23" name="TextBox 22"/>
+          <p:cNvSpPr txBox="1"/>
+          <p:nvPr/>
+        </p:nvSpPr>
+        <p:spPr>
+          <a:xfrm>
+            <a:off x="950976" y="5175504"/>
+            <a:ext cx="5157216" cy="329184"/>
           </a:xfrm>
           <a:prstGeom prst="rect">
             <a:avLst/>
@@ -6706,80 +8064,21 @@
                 </a:solidFill>
                 <a:latin typeface="Menlo"/>
               </a:rPr>
-              <a:t>6. vtlin_v  4.30%  @ (2.7, 0.28)</a:t>
-            </a:r>
-          </a:p>
-        </p:txBody>
-      </p:sp>
-      <p:sp>
-        <p:nvSpPr>
-          <p:cNvPr id="12" name="TextBox 11"/>
-          <p:cNvSpPr txBox="1"/>
-          <p:nvPr/>
-        </p:nvSpPr>
-        <p:spPr>
-          <a:xfrm>
-            <a:off x="768096" y="4041648"/>
-            <a:ext cx="5285232" cy="1755648"/>
-          </a:xfrm>
-          <a:prstGeom prst="rect">
-            <a:avLst/>
-          </a:prstGeom>
-          <a:noFill/>
-        </p:spPr>
-        <p:txBody>
-          <a:bodyPr wrap="square">
-            <a:spAutoFit/>
-          </a:bodyPr>
-          <a:lstStyle/>
-          <a:p>
-            <a:pPr algn="l"/>
-            <a:r>
-              <a:rPr sz="1800">
-                <a:solidFill>
-                  <a:srgbClr val="17324D"/>
-                </a:solidFill>
-                <a:latin typeface="PingFang SC"/>
-              </a:rPr>
-              <a:t>最坏点集中在较小或中等尺寸组合，不是单纯的大尺寸外推问题。</a:t>
-            </a:r>
-          </a:p>
-          <a:p>
-            <a:pPr algn="l"/>
-            <a:r>
-              <a:rPr sz="1800">
-                <a:solidFill>
-                  <a:srgbClr val="17324D"/>
-                </a:solidFill>
-                <a:latin typeface="PingFang SC"/>
-              </a:rPr>
-              <a:t>当前直接给漏电指标加权并没有改善 worst-case，说明问题不只是目标函数权重配置。</a:t>
-            </a:r>
-          </a:p>
-          <a:p>
-            <a:pPr algn="l"/>
-            <a:r>
-              <a:rPr sz="1800">
-                <a:solidFill>
-                  <a:srgbClr val="17324D"/>
-                </a:solidFill>
-                <a:latin typeface="PingFang SC"/>
-              </a:rPr>
-              <a:t>更值得优先尝试的是增加角点搜索和局部精修预算，而不是先重写优化器。</a:t>
-            </a:r>
-          </a:p>
-        </p:txBody>
-      </p:sp>
-      <p:sp>
-        <p:nvSpPr>
-          <p:cNvPr id="13" name="Rounded Rectangle 12"/>
+              <a:t>idsat_a     3.85%  @ W=1.5, L=0.056</a:t>
+            </a:r>
+          </a:p>
+        </p:txBody>
+      </p:sp>
+      <p:sp>
+        <p:nvSpPr>
+          <p:cNvPr id="24" name="Rounded Rectangle 23"/>
           <p:cNvSpPr/>
           <p:nvPr/>
         </p:nvSpPr>
         <p:spPr>
           <a:xfrm>
-            <a:off x="6419088" y="1024128"/>
-            <a:ext cx="2414016" cy="5230368"/>
+            <a:off x="6528816" y="1993392"/>
+            <a:ext cx="4992624" cy="4224528"/>
           </a:xfrm>
           <a:prstGeom prst="roundRect">
             <a:avLst/>
@@ -6817,14 +8116,14 @@
       </p:sp>
       <p:sp>
         <p:nvSpPr>
-          <p:cNvPr id="14" name="TextBox 13"/>
-          <p:cNvSpPr txBox="1"/>
-          <p:nvPr/>
-        </p:nvSpPr>
-        <p:spPr>
-          <a:xfrm>
-            <a:off x="6583679" y="1115568"/>
-            <a:ext cx="2084832" cy="274320"/>
+          <p:cNvPr id="25" name="TextBox 24"/>
+          <p:cNvSpPr txBox="1"/>
+          <p:nvPr/>
+        </p:nvSpPr>
+        <p:spPr>
+          <a:xfrm>
+            <a:off x="6693407" y="2084832"/>
+            <a:ext cx="4663440" cy="274320"/>
           </a:xfrm>
           <a:prstGeom prst="rect">
             <a:avLst/>
@@ -6845,14 +8144,14 @@
                 </a:solidFill>
                 <a:latin typeface="PingFang SC"/>
               </a:rPr>
-              <a:t>idoff heatmap</a:t>
+              <a:t>idoff target vs simulated</a:t>
             </a:r>
           </a:p>
         </p:txBody>
       </p:sp>
       <p:pic>
         <p:nvPicPr>
-          <p:cNvPr id="15" name="Picture 14" descr="error_heatmap_idoff_a.png"/>
+          <p:cNvPr id="26" name="Picture 25" descr="target_vs_simulated_idoff_a.png"/>
           <p:cNvPicPr>
             <a:picLocks noChangeAspect="1"/>
           </p:cNvPicPr>
@@ -6866,112 +8165,8 @@
         </p:blipFill>
         <p:spPr>
           <a:xfrm>
-            <a:off x="6556248" y="1463040"/>
-            <a:ext cx="2139696" cy="4654296"/>
-          </a:xfrm>
-          <a:prstGeom prst="rect">
-            <a:avLst/>
-          </a:prstGeom>
-        </p:spPr>
-      </p:pic>
-      <p:sp>
-        <p:nvSpPr>
-          <p:cNvPr id="16" name="Rounded Rectangle 15"/>
-          <p:cNvSpPr/>
-          <p:nvPr/>
-        </p:nvSpPr>
-        <p:spPr>
-          <a:xfrm>
-            <a:off x="9070848" y="1024128"/>
-            <a:ext cx="2414016" cy="5230368"/>
-          </a:xfrm>
-          <a:prstGeom prst="roundRect">
-            <a:avLst/>
-          </a:prstGeom>
-          <a:solidFill>
-            <a:srgbClr val="FFFDFC"/>
-          </a:solidFill>
-          <a:ln>
-            <a:solidFill>
-              <a:srgbClr val="D9CDB8"/>
-            </a:solidFill>
-          </a:ln>
-        </p:spPr>
-        <p:style>
-          <a:lnRef idx="1">
-            <a:schemeClr val="accent1"/>
-          </a:lnRef>
-          <a:fillRef idx="3">
-            <a:schemeClr val="accent1"/>
-          </a:fillRef>
-          <a:effectRef idx="2">
-            <a:schemeClr val="accent1"/>
-          </a:effectRef>
-          <a:fontRef idx="minor">
-            <a:schemeClr val="lt1"/>
-          </a:fontRef>
-        </p:style>
-        <p:txBody>
-          <a:bodyPr rtlCol="0" anchor="ctr"/>
-          <a:lstStyle/>
-          <a:p>
-            <a:pPr algn="ctr"/>
-          </a:p>
-        </p:txBody>
-      </p:sp>
-      <p:sp>
-        <p:nvSpPr>
-          <p:cNvPr id="17" name="TextBox 16"/>
-          <p:cNvSpPr txBox="1"/>
-          <p:nvPr/>
-        </p:nvSpPr>
-        <p:spPr>
-          <a:xfrm>
-            <a:off x="9235440" y="1115568"/>
-            <a:ext cx="2084832" cy="274320"/>
-          </a:xfrm>
-          <a:prstGeom prst="rect">
-            <a:avLst/>
-          </a:prstGeom>
-          <a:noFill/>
-        </p:spPr>
-        <p:txBody>
-          <a:bodyPr wrap="square">
-            <a:spAutoFit/>
-          </a:bodyPr>
-          <a:lstStyle/>
-          <a:p>
-            <a:pPr algn="l"/>
-            <a:r>
-              <a:rPr sz="1600" b="1">
-                <a:solidFill>
-                  <a:srgbClr val="17324D"/>
-                </a:solidFill>
-                <a:latin typeface="PingFang SC"/>
-              </a:rPr>
-              <a:t>isoff heatmap</a:t>
-            </a:r>
-          </a:p>
-        </p:txBody>
-      </p:sp>
-      <p:pic>
-        <p:nvPicPr>
-          <p:cNvPr id="18" name="Picture 17" descr="error_heatmap_isoff_a.png"/>
-          <p:cNvPicPr>
-            <a:picLocks noChangeAspect="1"/>
-          </p:cNvPicPr>
-          <p:nvPr/>
-        </p:nvPicPr>
-        <p:blipFill>
-          <a:blip r:embed="rId3"/>
-          <a:stretch>
-            <a:fillRect/>
-          </a:stretch>
-        </p:blipFill>
-        <p:spPr>
-          <a:xfrm>
-            <a:off x="9208008" y="1463040"/>
-            <a:ext cx="2139696" cy="4654296"/>
+            <a:off x="6665976" y="2432304"/>
+            <a:ext cx="4718304" cy="3648456"/>
           </a:xfrm>
           <a:prstGeom prst="rect">
             <a:avLst/>
@@ -7048,7 +8243,7 @@
         <p:spPr>
           <a:xfrm>
             <a:off x="658368" y="402336"/>
-            <a:ext cx="4206240" cy="438912"/>
+            <a:ext cx="2926080" cy="438912"/>
           </a:xfrm>
           <a:prstGeom prst="rect">
             <a:avLst/>
@@ -7069,68 +8264,21 @@
                 </a:solidFill>
                 <a:latin typeface="PingFang SC"/>
               </a:rPr>
-              <a:t>6. 参数趋势图：随 W 变化</a:t>
-            </a:r>
-          </a:p>
-        </p:txBody>
-      </p:sp>
-      <p:sp>
-        <p:nvSpPr>
-          <p:cNvPr id="4" name="TextBox 3"/>
-          <p:cNvSpPr txBox="1"/>
-          <p:nvPr/>
-        </p:nvSpPr>
-        <p:spPr>
-          <a:xfrm>
-            <a:off x="749808" y="950976"/>
-            <a:ext cx="4279392" cy="1005840"/>
-          </a:xfrm>
-          <a:prstGeom prst="rect">
-            <a:avLst/>
-          </a:prstGeom>
-          <a:noFill/>
-        </p:spPr>
-        <p:txBody>
-          <a:bodyPr wrap="square">
-            <a:spAutoFit/>
-          </a:bodyPr>
-          <a:lstStyle/>
-          <a:p>
-            <a:pPr algn="l"/>
-            <a:r>
-              <a:rPr sz="1800">
-                <a:solidFill>
-                  <a:srgbClr val="17324D"/>
-                </a:solidFill>
-                <a:latin typeface="PingFang SC"/>
-              </a:rPr>
-              <a:t>每个子图对应一个校准参数，横轴为 W，不同 L 为多条曲线。</a:t>
-            </a:r>
-          </a:p>
-          <a:p>
-            <a:pPr algn="l"/>
-            <a:r>
-              <a:rPr sz="1800">
-                <a:solidFill>
-                  <a:srgbClr val="17324D"/>
-                </a:solidFill>
-                <a:latin typeface="PingFang SC"/>
-              </a:rPr>
-              <a:t>该视图更适合检查宽度扩展时参数是否出现突跳或异常扭曲。</a:t>
-            </a:r>
-          </a:p>
-        </p:txBody>
-      </p:sp>
-      <p:sp>
-        <p:nvSpPr>
-          <p:cNvPr id="5" name="Rounded Rectangle 4"/>
+              <a:t>6. 误差热点</a:t>
+            </a:r>
+          </a:p>
+        </p:txBody>
+      </p:sp>
+      <p:sp>
+        <p:nvSpPr>
+          <p:cNvPr id="4" name="Rounded Rectangle 3"/>
           <p:cNvSpPr/>
           <p:nvPr/>
         </p:nvSpPr>
         <p:spPr>
           <a:xfrm>
-            <a:off x="749808" y="1847088"/>
-            <a:ext cx="10771632" cy="4370832"/>
+            <a:off x="749808" y="1078992"/>
+            <a:ext cx="5248656" cy="2697480"/>
           </a:xfrm>
           <a:prstGeom prst="roundRect">
             <a:avLst/>
@@ -7168,14 +8316,363 @@
       </p:sp>
       <p:sp>
         <p:nvSpPr>
+          <p:cNvPr id="5" name="TextBox 4"/>
+          <p:cNvSpPr txBox="1"/>
+          <p:nvPr/>
+        </p:nvSpPr>
+        <p:spPr>
+          <a:xfrm>
+            <a:off x="914400" y="1188719"/>
+            <a:ext cx="4919472" cy="274320"/>
+          </a:xfrm>
+          <a:prstGeom prst="rect">
+            <a:avLst/>
+          </a:prstGeom>
+          <a:noFill/>
+        </p:spPr>
+        <p:txBody>
+          <a:bodyPr wrap="square">
+            <a:spAutoFit/>
+          </a:bodyPr>
+          <a:lstStyle/>
+          <a:p>
+            <a:pPr algn="l"/>
+            <a:r>
+              <a:rPr sz="1600" b="1">
+                <a:solidFill>
+                  <a:srgbClr val="17324D"/>
+                </a:solidFill>
+                <a:latin typeface="PingFang SC"/>
+              </a:rPr>
+              <a:t>Top error points</a:t>
+            </a:r>
+          </a:p>
+        </p:txBody>
+      </p:sp>
+      <p:sp>
+        <p:nvSpPr>
           <p:cNvPr id="6" name="TextBox 5"/>
           <p:cNvSpPr txBox="1"/>
           <p:nvPr/>
         </p:nvSpPr>
         <p:spPr>
           <a:xfrm>
-            <a:off x="914400" y="1938528"/>
-            <a:ext cx="10442448" cy="274320"/>
+            <a:off x="950976" y="1591056"/>
+            <a:ext cx="4846320" cy="329184"/>
+          </a:xfrm>
+          <a:prstGeom prst="rect">
+            <a:avLst/>
+          </a:prstGeom>
+          <a:noFill/>
+        </p:spPr>
+        <p:txBody>
+          <a:bodyPr wrap="square">
+            <a:spAutoFit/>
+          </a:bodyPr>
+          <a:lstStyle/>
+          <a:p>
+            <a:pPr algn="l"/>
+            <a:r>
+              <a:rPr sz="1300" b="0">
+                <a:solidFill>
+                  <a:srgbClr val="17324D"/>
+                </a:solidFill>
+                <a:latin typeface="Menlo"/>
+              </a:rPr>
+              <a:t>1. idoff_a  5.10%  @ (0.56, 1.5)</a:t>
+            </a:r>
+          </a:p>
+        </p:txBody>
+      </p:sp>
+      <p:sp>
+        <p:nvSpPr>
+          <p:cNvPr id="7" name="TextBox 6"/>
+          <p:cNvSpPr txBox="1"/>
+          <p:nvPr/>
+        </p:nvSpPr>
+        <p:spPr>
+          <a:xfrm>
+            <a:off x="950976" y="1975104"/>
+            <a:ext cx="4846320" cy="329184"/>
+          </a:xfrm>
+          <a:prstGeom prst="rect">
+            <a:avLst/>
+          </a:prstGeom>
+          <a:noFill/>
+        </p:spPr>
+        <p:txBody>
+          <a:bodyPr wrap="square">
+            <a:spAutoFit/>
+          </a:bodyPr>
+          <a:lstStyle/>
+          <a:p>
+            <a:pPr algn="l"/>
+            <a:r>
+              <a:rPr sz="1300" b="0">
+                <a:solidFill>
+                  <a:srgbClr val="17324D"/>
+                </a:solidFill>
+                <a:latin typeface="Menlo"/>
+              </a:rPr>
+              <a:t>2. idoff_a  5.10%  @ (0.14, 0.028)</a:t>
+            </a:r>
+          </a:p>
+        </p:txBody>
+      </p:sp>
+      <p:sp>
+        <p:nvSpPr>
+          <p:cNvPr id="8" name="TextBox 7"/>
+          <p:cNvSpPr txBox="1"/>
+          <p:nvPr/>
+        </p:nvSpPr>
+        <p:spPr>
+          <a:xfrm>
+            <a:off x="950976" y="2359152"/>
+            <a:ext cx="4846320" cy="329184"/>
+          </a:xfrm>
+          <a:prstGeom prst="rect">
+            <a:avLst/>
+          </a:prstGeom>
+          <a:noFill/>
+        </p:spPr>
+        <p:txBody>
+          <a:bodyPr wrap="square">
+            <a:spAutoFit/>
+          </a:bodyPr>
+          <a:lstStyle/>
+          <a:p>
+            <a:pPr algn="l"/>
+            <a:r>
+              <a:rPr sz="1300" b="0">
+                <a:solidFill>
+                  <a:srgbClr val="17324D"/>
+                </a:solidFill>
+                <a:latin typeface="Menlo"/>
+              </a:rPr>
+              <a:t>3. isoff_a  4.89%  @ (0.56, 1.5)</a:t>
+            </a:r>
+          </a:p>
+        </p:txBody>
+      </p:sp>
+      <p:sp>
+        <p:nvSpPr>
+          <p:cNvPr id="9" name="TextBox 8"/>
+          <p:cNvSpPr txBox="1"/>
+          <p:nvPr/>
+        </p:nvSpPr>
+        <p:spPr>
+          <a:xfrm>
+            <a:off x="950976" y="2743200"/>
+            <a:ext cx="4846320" cy="329184"/>
+          </a:xfrm>
+          <a:prstGeom prst="rect">
+            <a:avLst/>
+          </a:prstGeom>
+          <a:noFill/>
+        </p:spPr>
+        <p:txBody>
+          <a:bodyPr wrap="square">
+            <a:spAutoFit/>
+          </a:bodyPr>
+          <a:lstStyle/>
+          <a:p>
+            <a:pPr algn="l"/>
+            <a:r>
+              <a:rPr sz="1300" b="0">
+                <a:solidFill>
+                  <a:srgbClr val="17324D"/>
+                </a:solidFill>
+                <a:latin typeface="Menlo"/>
+              </a:rPr>
+              <a:t>4. isoff_a  4.39%  @ (2.7, 0.28)</a:t>
+            </a:r>
+          </a:p>
+        </p:txBody>
+      </p:sp>
+      <p:sp>
+        <p:nvSpPr>
+          <p:cNvPr id="10" name="TextBox 9"/>
+          <p:cNvSpPr txBox="1"/>
+          <p:nvPr/>
+        </p:nvSpPr>
+        <p:spPr>
+          <a:xfrm>
+            <a:off x="950976" y="3127248"/>
+            <a:ext cx="4846320" cy="329184"/>
+          </a:xfrm>
+          <a:prstGeom prst="rect">
+            <a:avLst/>
+          </a:prstGeom>
+          <a:noFill/>
+        </p:spPr>
+        <p:txBody>
+          <a:bodyPr wrap="square">
+            <a:spAutoFit/>
+          </a:bodyPr>
+          <a:lstStyle/>
+          <a:p>
+            <a:pPr algn="l"/>
+            <a:r>
+              <a:rPr sz="1300" b="0">
+                <a:solidFill>
+                  <a:srgbClr val="17324D"/>
+                </a:solidFill>
+                <a:latin typeface="Menlo"/>
+              </a:rPr>
+              <a:t>5. idoff_a  4.36%  @ (0.28, 0.56)</a:t>
+            </a:r>
+          </a:p>
+        </p:txBody>
+      </p:sp>
+      <p:sp>
+        <p:nvSpPr>
+          <p:cNvPr id="11" name="TextBox 10"/>
+          <p:cNvSpPr txBox="1"/>
+          <p:nvPr/>
+        </p:nvSpPr>
+        <p:spPr>
+          <a:xfrm>
+            <a:off x="950976" y="3511296"/>
+            <a:ext cx="4846320" cy="329184"/>
+          </a:xfrm>
+          <a:prstGeom prst="rect">
+            <a:avLst/>
+          </a:prstGeom>
+          <a:noFill/>
+        </p:spPr>
+        <p:txBody>
+          <a:bodyPr wrap="square">
+            <a:spAutoFit/>
+          </a:bodyPr>
+          <a:lstStyle/>
+          <a:p>
+            <a:pPr algn="l"/>
+            <a:r>
+              <a:rPr sz="1300" b="0">
+                <a:solidFill>
+                  <a:srgbClr val="17324D"/>
+                </a:solidFill>
+                <a:latin typeface="Menlo"/>
+              </a:rPr>
+              <a:t>6. vtlin_v  4.30%  @ (2.7, 0.28)</a:t>
+            </a:r>
+          </a:p>
+        </p:txBody>
+      </p:sp>
+      <p:sp>
+        <p:nvSpPr>
+          <p:cNvPr id="12" name="TextBox 11"/>
+          <p:cNvSpPr txBox="1"/>
+          <p:nvPr/>
+        </p:nvSpPr>
+        <p:spPr>
+          <a:xfrm>
+            <a:off x="768096" y="4041648"/>
+            <a:ext cx="5285232" cy="1755648"/>
+          </a:xfrm>
+          <a:prstGeom prst="rect">
+            <a:avLst/>
+          </a:prstGeom>
+          <a:noFill/>
+        </p:spPr>
+        <p:txBody>
+          <a:bodyPr wrap="square">
+            <a:spAutoFit/>
+          </a:bodyPr>
+          <a:lstStyle/>
+          <a:p>
+            <a:pPr algn="l"/>
+            <a:r>
+              <a:rPr sz="1800">
+                <a:solidFill>
+                  <a:srgbClr val="17324D"/>
+                </a:solidFill>
+                <a:latin typeface="PingFang SC"/>
+              </a:rPr>
+              <a:t>最坏点集中在较小或中等尺寸组合，不是单纯的大尺寸外推问题。</a:t>
+            </a:r>
+          </a:p>
+          <a:p>
+            <a:pPr algn="l"/>
+            <a:r>
+              <a:rPr sz="1800">
+                <a:solidFill>
+                  <a:srgbClr val="17324D"/>
+                </a:solidFill>
+                <a:latin typeface="PingFang SC"/>
+              </a:rPr>
+              <a:t>当前直接给漏电指标加权并没有改善 worst-case，说明问题不只是目标函数权重配置。</a:t>
+            </a:r>
+          </a:p>
+          <a:p>
+            <a:pPr algn="l"/>
+            <a:r>
+              <a:rPr sz="1800">
+                <a:solidFill>
+                  <a:srgbClr val="17324D"/>
+                </a:solidFill>
+                <a:latin typeface="PingFang SC"/>
+              </a:rPr>
+              <a:t>更值得优先尝试的是增加角点搜索和局部精修预算，而不是先重写优化器。</a:t>
+            </a:r>
+          </a:p>
+        </p:txBody>
+      </p:sp>
+      <p:sp>
+        <p:nvSpPr>
+          <p:cNvPr id="13" name="Rounded Rectangle 12"/>
+          <p:cNvSpPr/>
+          <p:nvPr/>
+        </p:nvSpPr>
+        <p:spPr>
+          <a:xfrm>
+            <a:off x="6419088" y="1024128"/>
+            <a:ext cx="2414016" cy="5230368"/>
+          </a:xfrm>
+          <a:prstGeom prst="roundRect">
+            <a:avLst/>
+          </a:prstGeom>
+          <a:solidFill>
+            <a:srgbClr val="FFFDFC"/>
+          </a:solidFill>
+          <a:ln>
+            <a:solidFill>
+              <a:srgbClr val="D9CDB8"/>
+            </a:solidFill>
+          </a:ln>
+        </p:spPr>
+        <p:style>
+          <a:lnRef idx="1">
+            <a:schemeClr val="accent1"/>
+          </a:lnRef>
+          <a:fillRef idx="3">
+            <a:schemeClr val="accent1"/>
+          </a:fillRef>
+          <a:effectRef idx="2">
+            <a:schemeClr val="accent1"/>
+          </a:effectRef>
+          <a:fontRef idx="minor">
+            <a:schemeClr val="lt1"/>
+          </a:fontRef>
+        </p:style>
+        <p:txBody>
+          <a:bodyPr rtlCol="0" anchor="ctr"/>
+          <a:lstStyle/>
+          <a:p>
+            <a:pPr algn="ctr"/>
+          </a:p>
+        </p:txBody>
+      </p:sp>
+      <p:sp>
+        <p:nvSpPr>
+          <p:cNvPr id="14" name="TextBox 13"/>
+          <p:cNvSpPr txBox="1"/>
+          <p:nvPr/>
+        </p:nvSpPr>
+        <p:spPr>
+          <a:xfrm>
+            <a:off x="6583679" y="1115568"/>
+            <a:ext cx="2084832" cy="274320"/>
           </a:xfrm>
           <a:prstGeom prst="rect">
             <a:avLst/>
@@ -7196,14 +8693,14 @@
                 </a:solidFill>
                 <a:latin typeface="PingFang SC"/>
               </a:rPr>
-              <a:t>parameter_trends_vs_w.png</a:t>
+              <a:t>idoff heatmap</a:t>
             </a:r>
           </a:p>
         </p:txBody>
       </p:sp>
       <p:pic>
         <p:nvPicPr>
-          <p:cNvPr id="7" name="Picture 6" descr="parameter_trends_vs_w.png"/>
+          <p:cNvPr id="15" name="Picture 14" descr="error_heatmap_idoff_a.png"/>
           <p:cNvPicPr>
             <a:picLocks noChangeAspect="1"/>
           </p:cNvPicPr>
@@ -7217,8 +8714,112 @@
         </p:blipFill>
         <p:spPr>
           <a:xfrm>
-            <a:off x="886968" y="2286000"/>
-            <a:ext cx="10497311" cy="3794760"/>
+            <a:off x="6556248" y="1463040"/>
+            <a:ext cx="2139696" cy="4654296"/>
+          </a:xfrm>
+          <a:prstGeom prst="rect">
+            <a:avLst/>
+          </a:prstGeom>
+        </p:spPr>
+      </p:pic>
+      <p:sp>
+        <p:nvSpPr>
+          <p:cNvPr id="16" name="Rounded Rectangle 15"/>
+          <p:cNvSpPr/>
+          <p:nvPr/>
+        </p:nvSpPr>
+        <p:spPr>
+          <a:xfrm>
+            <a:off x="9070848" y="1024128"/>
+            <a:ext cx="2414016" cy="5230368"/>
+          </a:xfrm>
+          <a:prstGeom prst="roundRect">
+            <a:avLst/>
+          </a:prstGeom>
+          <a:solidFill>
+            <a:srgbClr val="FFFDFC"/>
+          </a:solidFill>
+          <a:ln>
+            <a:solidFill>
+              <a:srgbClr val="D9CDB8"/>
+            </a:solidFill>
+          </a:ln>
+        </p:spPr>
+        <p:style>
+          <a:lnRef idx="1">
+            <a:schemeClr val="accent1"/>
+          </a:lnRef>
+          <a:fillRef idx="3">
+            <a:schemeClr val="accent1"/>
+          </a:fillRef>
+          <a:effectRef idx="2">
+            <a:schemeClr val="accent1"/>
+          </a:effectRef>
+          <a:fontRef idx="minor">
+            <a:schemeClr val="lt1"/>
+          </a:fontRef>
+        </p:style>
+        <p:txBody>
+          <a:bodyPr rtlCol="0" anchor="ctr"/>
+          <a:lstStyle/>
+          <a:p>
+            <a:pPr algn="ctr"/>
+          </a:p>
+        </p:txBody>
+      </p:sp>
+      <p:sp>
+        <p:nvSpPr>
+          <p:cNvPr id="17" name="TextBox 16"/>
+          <p:cNvSpPr txBox="1"/>
+          <p:nvPr/>
+        </p:nvSpPr>
+        <p:spPr>
+          <a:xfrm>
+            <a:off x="9235440" y="1115568"/>
+            <a:ext cx="2084832" cy="274320"/>
+          </a:xfrm>
+          <a:prstGeom prst="rect">
+            <a:avLst/>
+          </a:prstGeom>
+          <a:noFill/>
+        </p:spPr>
+        <p:txBody>
+          <a:bodyPr wrap="square">
+            <a:spAutoFit/>
+          </a:bodyPr>
+          <a:lstStyle/>
+          <a:p>
+            <a:pPr algn="l"/>
+            <a:r>
+              <a:rPr sz="1600" b="1">
+                <a:solidFill>
+                  <a:srgbClr val="17324D"/>
+                </a:solidFill>
+                <a:latin typeface="PingFang SC"/>
+              </a:rPr>
+              <a:t>isoff heatmap</a:t>
+            </a:r>
+          </a:p>
+        </p:txBody>
+      </p:sp>
+      <p:pic>
+        <p:nvPicPr>
+          <p:cNvPr id="18" name="Picture 17" descr="error_heatmap_isoff_a.png"/>
+          <p:cNvPicPr>
+            <a:picLocks noChangeAspect="1"/>
+          </p:cNvPicPr>
+          <p:nvPr/>
+        </p:nvPicPr>
+        <p:blipFill>
+          <a:blip r:embed="rId3"/>
+          <a:stretch>
+            <a:fillRect/>
+          </a:stretch>
+        </p:blipFill>
+        <p:spPr>
+          <a:xfrm>
+            <a:off x="9208008" y="1463040"/>
+            <a:ext cx="2139696" cy="4654296"/>
           </a:xfrm>
           <a:prstGeom prst="rect">
             <a:avLst/>
@@ -7316,7 +8917,7 @@
                 </a:solidFill>
                 <a:latin typeface="PingFang SC"/>
               </a:rPr>
-              <a:t>7. 参数趋势图：随 L 变化</a:t>
+              <a:t>7. 参数趋势图：随 W 变化</a:t>
             </a:r>
           </a:p>
         </p:txBody>
@@ -7351,7 +8952,7 @@
                 </a:solidFill>
                 <a:latin typeface="PingFang SC"/>
               </a:rPr>
-              <a:t>每个子图横轴为 L，不同 W 为多条曲线。</a:t>
+              <a:t>每个子图对应一个校准参数，横轴为 W，不同 L 为多条曲线。</a:t>
             </a:r>
           </a:p>
           <a:p>
@@ -7363,7 +8964,7 @@
                 </a:solidFill>
                 <a:latin typeface="PingFang SC"/>
               </a:rPr>
-              <a:t>与上一页组合后，可以更系统地判断参数曲面对尺寸的整体响应是否平滑一致。</a:t>
+              <a:t>该视图更适合检查宽度扩展时参数是否出现突跳或异常扭曲。</a:t>
             </a:r>
           </a:p>
         </p:txBody>
@@ -7443,14 +9044,14 @@
                 </a:solidFill>
                 <a:latin typeface="PingFang SC"/>
               </a:rPr>
-              <a:t>parameter_trends_vs_l.png</a:t>
+              <a:t>parameter_trends_vs_w.png</a:t>
             </a:r>
           </a:p>
         </p:txBody>
       </p:sp>
       <p:pic>
         <p:nvPicPr>
-          <p:cNvPr id="7" name="Picture 6" descr="parameter_trends_vs_l.png"/>
+          <p:cNvPr id="7" name="Picture 6" descr="parameter_trends_vs_w.png"/>
           <p:cNvPicPr>
             <a:picLocks noChangeAspect="1"/>
           </p:cNvPicPr>
@@ -7542,7 +9143,7 @@
         <p:spPr>
           <a:xfrm>
             <a:off x="658368" y="402336"/>
-            <a:ext cx="3108960" cy="438912"/>
+            <a:ext cx="4206240" cy="438912"/>
           </a:xfrm>
           <a:prstGeom prst="rect">
             <a:avLst/>
@@ -7563,7 +9164,7 @@
                 </a:solidFill>
                 <a:latin typeface="PingFang SC"/>
               </a:rPr>
-              <a:t>8. 下一步建议</a:t>
+              <a:t>8. 参数趋势图：随 L 变化</a:t>
             </a:r>
           </a:p>
         </p:txBody>
@@ -7576,8 +9177,8 @@
         </p:nvSpPr>
         <p:spPr>
           <a:xfrm>
-            <a:off x="749808" y="1078992"/>
-            <a:ext cx="6492240" cy="3474720"/>
+            <a:off x="749808" y="950976"/>
+            <a:ext cx="4279392" cy="1005840"/>
           </a:xfrm>
           <a:prstGeom prst="rect">
             <a:avLst/>
@@ -7598,7 +9199,7 @@
                 </a:solidFill>
                 <a:latin typeface="PingFang SC"/>
               </a:rPr>
-              <a:t>先固化当前默认基线和本轮带趋势图的结果目录，避免后续实验覆盖。</a:t>
+              <a:t>每个子图横轴为 L，不同 W 为多条曲线。</a:t>
             </a:r>
           </a:p>
           <a:p>
@@ -7610,31 +9211,7 @@
                 </a:solidFill>
                 <a:latin typeface="PingFang SC"/>
               </a:rPr>
-              <a:t>围绕 idoff_a / isoff_a 做更聚焦的敏感度分析，识别真正主导 leakage 的参数组合。</a:t>
-            </a:r>
-          </a:p>
-          <a:p>
-            <a:pPr algn="l"/>
-            <a:r>
-              <a:rPr sz="1800">
-                <a:solidFill>
-                  <a:srgbClr val="17324D"/>
-                </a:solidFill>
-                <a:latin typeface="PingFang SC"/>
-              </a:rPr>
-              <a:t>优先增加 NSGA-II 和局部 refinement 预算，再判断是否需要更强的 refit 或特化优化器。</a:t>
-            </a:r>
-          </a:p>
-          <a:p>
-            <a:pPr algn="l"/>
-            <a:r>
-              <a:rPr sz="1800">
-                <a:solidFill>
-                  <a:srgbClr val="17324D"/>
-                </a:solidFill>
-                <a:latin typeface="PingFang SC"/>
-              </a:rPr>
-              <a:t>如果后续要评估非训练点泛化，再单独加强全局连续模型，而不是与训练点拟合问题混在一起。</a:t>
+              <a:t>与上一页组合后，可以更系统地判断参数曲面对尺寸的整体响应是否平滑一致。</a:t>
             </a:r>
           </a:p>
         </p:txBody>
@@ -7647,158 +9224,8 @@
         </p:nvSpPr>
         <p:spPr>
           <a:xfrm>
-            <a:off x="786384" y="4919472"/>
-            <a:ext cx="3931920" cy="1188720"/>
-          </a:xfrm>
-          <a:prstGeom prst="roundRect">
-            <a:avLst/>
-          </a:prstGeom>
-          <a:solidFill>
-            <a:srgbClr val="FFFDFC"/>
-          </a:solidFill>
-          <a:ln w="27432">
-            <a:solidFill>
-              <a:srgbClr val="F3B33D"/>
-            </a:solidFill>
-          </a:ln>
-        </p:spPr>
-        <p:style>
-          <a:lnRef idx="1">
-            <a:schemeClr val="accent1"/>
-          </a:lnRef>
-          <a:fillRef idx="3">
-            <a:schemeClr val="accent1"/>
-          </a:fillRef>
-          <a:effectRef idx="2">
-            <a:schemeClr val="accent1"/>
-          </a:effectRef>
-          <a:fontRef idx="minor">
-            <a:schemeClr val="lt1"/>
-          </a:fontRef>
-        </p:style>
-        <p:txBody>
-          <a:bodyPr rtlCol="0" anchor="ctr"/>
-          <a:lstStyle/>
-          <a:p>
-            <a:pPr algn="ctr"/>
-          </a:p>
-        </p:txBody>
-      </p:sp>
-      <p:sp>
-        <p:nvSpPr>
-          <p:cNvPr id="6" name="TextBox 5"/>
-          <p:cNvSpPr txBox="1"/>
-          <p:nvPr/>
-        </p:nvSpPr>
-        <p:spPr>
-          <a:xfrm>
-            <a:off x="950976" y="5084064"/>
-            <a:ext cx="3602736" cy="320040"/>
-          </a:xfrm>
-          <a:prstGeom prst="rect">
-            <a:avLst/>
-          </a:prstGeom>
-          <a:noFill/>
-        </p:spPr>
-        <p:txBody>
-          <a:bodyPr wrap="square">
-            <a:spAutoFit/>
-          </a:bodyPr>
-          <a:lstStyle/>
-          <a:p>
-            <a:pPr algn="l"/>
-            <a:r>
-              <a:rPr sz="1600" b="1">
-                <a:solidFill>
-                  <a:srgbClr val="5C6B73"/>
-                </a:solidFill>
-                <a:latin typeface="PingFang SC"/>
-              </a:rPr>
-              <a:t>建议优先级</a:t>
-            </a:r>
-          </a:p>
-        </p:txBody>
-      </p:sp>
-      <p:sp>
-        <p:nvSpPr>
-          <p:cNvPr id="7" name="TextBox 6"/>
-          <p:cNvSpPr txBox="1"/>
-          <p:nvPr/>
-        </p:nvSpPr>
-        <p:spPr>
-          <a:xfrm>
-            <a:off x="950976" y="5431536"/>
-            <a:ext cx="3602736" cy="502920"/>
-          </a:xfrm>
-          <a:prstGeom prst="rect">
-            <a:avLst/>
-          </a:prstGeom>
-          <a:noFill/>
-        </p:spPr>
-        <p:txBody>
-          <a:bodyPr wrap="square">
-            <a:spAutoFit/>
-          </a:bodyPr>
-          <a:lstStyle/>
-          <a:p>
-            <a:pPr algn="l"/>
-            <a:r>
-              <a:rPr sz="2500" b="1">
-                <a:solidFill>
-                  <a:srgbClr val="17324D"/>
-                </a:solidFill>
-                <a:latin typeface="PingFang SC"/>
-              </a:rPr>
-              <a:t>预算提升 &gt; 漏电加权 &gt; 重写算法</a:t>
-            </a:r>
-          </a:p>
-        </p:txBody>
-      </p:sp>
-      <p:sp>
-        <p:nvSpPr>
-          <p:cNvPr id="8" name="TextBox 7"/>
-          <p:cNvSpPr txBox="1"/>
-          <p:nvPr/>
-        </p:nvSpPr>
-        <p:spPr>
-          <a:xfrm>
-            <a:off x="950976" y="5907024"/>
-            <a:ext cx="3602736" cy="54864"/>
-          </a:xfrm>
-          <a:prstGeom prst="rect">
-            <a:avLst/>
-          </a:prstGeom>
-          <a:noFill/>
-        </p:spPr>
-        <p:txBody>
-          <a:bodyPr wrap="square">
-            <a:spAutoFit/>
-          </a:bodyPr>
-          <a:lstStyle/>
-          <a:p>
-            <a:pPr algn="l"/>
-            <a:r>
-              <a:rPr sz="1100" b="0">
-                <a:solidFill>
-                  <a:srgbClr val="5C6B73"/>
-                </a:solidFill>
-                <a:latin typeface="PingFang SC"/>
-              </a:rPr>
-              <a:t>本轮实验已表明直接漏电加权会让 worst-case 变差。</a:t>
-            </a:r>
-          </a:p>
-        </p:txBody>
-      </p:sp>
-      <p:sp>
-        <p:nvSpPr>
-          <p:cNvPr id="9" name="Rounded Rectangle 8"/>
-          <p:cNvSpPr/>
-          <p:nvPr/>
-        </p:nvSpPr>
-        <p:spPr>
-          <a:xfrm>
-            <a:off x="7662672" y="1078992"/>
-            <a:ext cx="1883664" cy="2304288"/>
+            <a:off x="749808" y="1847088"/>
+            <a:ext cx="10771632" cy="4370832"/>
           </a:xfrm>
           <a:prstGeom prst="roundRect">
             <a:avLst/>
@@ -7836,14 +9263,14 @@
       </p:sp>
       <p:sp>
         <p:nvSpPr>
-          <p:cNvPr id="10" name="TextBox 9"/>
-          <p:cNvSpPr txBox="1"/>
-          <p:nvPr/>
-        </p:nvSpPr>
-        <p:spPr>
-          <a:xfrm>
-            <a:off x="7827264" y="1170432"/>
-            <a:ext cx="1554480" cy="274320"/>
+          <p:cNvPr id="6" name="TextBox 5"/>
+          <p:cNvSpPr txBox="1"/>
+          <p:nvPr/>
+        </p:nvSpPr>
+        <p:spPr>
+          <a:xfrm>
+            <a:off x="914400" y="1938528"/>
+            <a:ext cx="10442448" cy="274320"/>
           </a:xfrm>
           <a:prstGeom prst="rect">
             <a:avLst/>
@@ -7864,14 +9291,14 @@
                 </a:solidFill>
                 <a:latin typeface="PingFang SC"/>
               </a:rPr>
-              <a:t>vtsat heatmap</a:t>
+              <a:t>parameter_trends_vs_l.png</a:t>
             </a:r>
           </a:p>
         </p:txBody>
       </p:sp>
       <p:pic>
         <p:nvPicPr>
-          <p:cNvPr id="11" name="Picture 10" descr="error_heatmap_vtsat_v.png"/>
+          <p:cNvPr id="7" name="Picture 6" descr="parameter_trends_vs_l.png"/>
           <p:cNvPicPr>
             <a:picLocks noChangeAspect="1"/>
           </p:cNvPicPr>
@@ -7885,216 +9312,8 @@
         </p:blipFill>
         <p:spPr>
           <a:xfrm>
-            <a:off x="7799832" y="1517904"/>
-            <a:ext cx="1609344" cy="1728216"/>
-          </a:xfrm>
-          <a:prstGeom prst="rect">
-            <a:avLst/>
-          </a:prstGeom>
-        </p:spPr>
-      </p:pic>
-      <p:sp>
-        <p:nvSpPr>
-          <p:cNvPr id="12" name="Rounded Rectangle 11"/>
-          <p:cNvSpPr/>
-          <p:nvPr/>
-        </p:nvSpPr>
-        <p:spPr>
-          <a:xfrm>
-            <a:off x="9637776" y="1078992"/>
-            <a:ext cx="1883664" cy="2304288"/>
-          </a:xfrm>
-          <a:prstGeom prst="roundRect">
-            <a:avLst/>
-          </a:prstGeom>
-          <a:solidFill>
-            <a:srgbClr val="FFFDFC"/>
-          </a:solidFill>
-          <a:ln>
-            <a:solidFill>
-              <a:srgbClr val="D9CDB8"/>
-            </a:solidFill>
-          </a:ln>
-        </p:spPr>
-        <p:style>
-          <a:lnRef idx="1">
-            <a:schemeClr val="accent1"/>
-          </a:lnRef>
-          <a:fillRef idx="3">
-            <a:schemeClr val="accent1"/>
-          </a:fillRef>
-          <a:effectRef idx="2">
-            <a:schemeClr val="accent1"/>
-          </a:effectRef>
-          <a:fontRef idx="minor">
-            <a:schemeClr val="lt1"/>
-          </a:fontRef>
-        </p:style>
-        <p:txBody>
-          <a:bodyPr rtlCol="0" anchor="ctr"/>
-          <a:lstStyle/>
-          <a:p>
-            <a:pPr algn="ctr"/>
-          </a:p>
-        </p:txBody>
-      </p:sp>
-      <p:sp>
-        <p:nvSpPr>
-          <p:cNvPr id="13" name="TextBox 12"/>
-          <p:cNvSpPr txBox="1"/>
-          <p:nvPr/>
-        </p:nvSpPr>
-        <p:spPr>
-          <a:xfrm>
-            <a:off x="9802367" y="1170432"/>
-            <a:ext cx="1554480" cy="274320"/>
-          </a:xfrm>
-          <a:prstGeom prst="rect">
-            <a:avLst/>
-          </a:prstGeom>
-          <a:noFill/>
-        </p:spPr>
-        <p:txBody>
-          <a:bodyPr wrap="square">
-            <a:spAutoFit/>
-          </a:bodyPr>
-          <a:lstStyle/>
-          <a:p>
-            <a:pPr algn="l"/>
-            <a:r>
-              <a:rPr sz="1600" b="1">
-                <a:solidFill>
-                  <a:srgbClr val="17324D"/>
-                </a:solidFill>
-                <a:latin typeface="PingFang SC"/>
-              </a:rPr>
-              <a:t>vtlin heatmap</a:t>
-            </a:r>
-          </a:p>
-        </p:txBody>
-      </p:sp>
-      <p:pic>
-        <p:nvPicPr>
-          <p:cNvPr id="14" name="Picture 13" descr="error_heatmap_vtlin_v.png"/>
-          <p:cNvPicPr>
-            <a:picLocks noChangeAspect="1"/>
-          </p:cNvPicPr>
-          <p:nvPr/>
-        </p:nvPicPr>
-        <p:blipFill>
-          <a:blip r:embed="rId3"/>
-          <a:stretch>
-            <a:fillRect/>
-          </a:stretch>
-        </p:blipFill>
-        <p:spPr>
-          <a:xfrm>
-            <a:off x="9774936" y="1517904"/>
-            <a:ext cx="1609344" cy="1728216"/>
-          </a:xfrm>
-          <a:prstGeom prst="rect">
-            <a:avLst/>
-          </a:prstGeom>
-        </p:spPr>
-      </p:pic>
-      <p:sp>
-        <p:nvSpPr>
-          <p:cNvPr id="15" name="Rounded Rectangle 14"/>
-          <p:cNvSpPr/>
-          <p:nvPr/>
-        </p:nvSpPr>
-        <p:spPr>
-          <a:xfrm>
-            <a:off x="7662672" y="3675887"/>
-            <a:ext cx="3858768" cy="2432304"/>
-          </a:xfrm>
-          <a:prstGeom prst="roundRect">
-            <a:avLst/>
-          </a:prstGeom>
-          <a:solidFill>
-            <a:srgbClr val="FFFDFC"/>
-          </a:solidFill>
-          <a:ln>
-            <a:solidFill>
-              <a:srgbClr val="D9CDB8"/>
-            </a:solidFill>
-          </a:ln>
-        </p:spPr>
-        <p:style>
-          <a:lnRef idx="1">
-            <a:schemeClr val="accent1"/>
-          </a:lnRef>
-          <a:fillRef idx="3">
-            <a:schemeClr val="accent1"/>
-          </a:fillRef>
-          <a:effectRef idx="2">
-            <a:schemeClr val="accent1"/>
-          </a:effectRef>
-          <a:fontRef idx="minor">
-            <a:schemeClr val="lt1"/>
-          </a:fontRef>
-        </p:style>
-        <p:txBody>
-          <a:bodyPr rtlCol="0" anchor="ctr"/>
-          <a:lstStyle/>
-          <a:p>
-            <a:pPr algn="ctr"/>
-          </a:p>
-        </p:txBody>
-      </p:sp>
-      <p:sp>
-        <p:nvSpPr>
-          <p:cNvPr id="16" name="TextBox 15"/>
-          <p:cNvSpPr txBox="1"/>
-          <p:nvPr/>
-        </p:nvSpPr>
-        <p:spPr>
-          <a:xfrm>
-            <a:off x="7827264" y="3767327"/>
-            <a:ext cx="3529584" cy="274320"/>
-          </a:xfrm>
-          <a:prstGeom prst="rect">
-            <a:avLst/>
-          </a:prstGeom>
-          <a:noFill/>
-        </p:spPr>
-        <p:txBody>
-          <a:bodyPr wrap="square">
-            <a:spAutoFit/>
-          </a:bodyPr>
-          <a:lstStyle/>
-          <a:p>
-            <a:pPr algn="l"/>
-            <a:r>
-              <a:rPr sz="1600" b="1">
-                <a:solidFill>
-                  <a:srgbClr val="17324D"/>
-                </a:solidFill>
-                <a:latin typeface="PingFang SC"/>
-              </a:rPr>
-              <a:t>pareto front</a:t>
-            </a:r>
-          </a:p>
-        </p:txBody>
-      </p:sp>
-      <p:pic>
-        <p:nvPicPr>
-          <p:cNvPr id="17" name="Picture 16" descr="pareto_front.png"/>
-          <p:cNvPicPr>
-            <a:picLocks noChangeAspect="1"/>
-          </p:cNvPicPr>
-          <p:nvPr/>
-        </p:nvPicPr>
-        <p:blipFill>
-          <a:blip r:embed="rId4"/>
-          <a:stretch>
-            <a:fillRect/>
-          </a:stretch>
-        </p:blipFill>
-        <p:spPr>
-          <a:xfrm>
-            <a:off x="7799832" y="4114800"/>
-            <a:ext cx="3584448" cy="1856232"/>
+            <a:off x="886968" y="2286000"/>
+            <a:ext cx="10497311" cy="3794760"/>
           </a:xfrm>
           <a:prstGeom prst="rect">
             <a:avLst/>

</xml_diff>